<commit_message>
Submission polish: green deck (13 slides, team) + detailed document, conservative 98/98/2 metrics, guardian-number sync in native app
</commit_message>
<xml_diff>
--- a/deck/DHAAL_pitch.pptx
+++ b/deck/DHAAL_pitch.pptx
@@ -17,9 +17,10 @@
     <p:sldId id="265" r:id="rId11"/>
     <p:sldId id="266" r:id="rId12"/>
     <p:sldId id="267" r:id="rId13"/>
+    <p:sldId id="268" r:id="rId14"/>
   </p:sldIdLst>
   <p:notesMasterIdLst>
-    <p:notesMasterId r:id="rId14"/>
+    <p:notesMasterId r:id="rId15"/>
   </p:notesMasterIdLst>
   <p:sldSz cx="12192000" cy="6858000"/>
   <p:notesSz cx="6858000" cy="12192000"/>
@@ -160,7 +161,7 @@
             <c:bubble3D val="0"/>
             <c:spPr>
               <a:solidFill>
-                <a:srgbClr val="2E5AA8"/>
+                <a:srgbClr val="1E8A5B"/>
               </a:solidFill>
               <a:effectLst/>
             </c:spPr>
@@ -180,7 +181,7 @@
             <c:bubble3D val="0"/>
             <c:spPr>
               <a:solidFill>
-                <a:srgbClr val="CADCFC"/>
+                <a:srgbClr val="CDE6D8"/>
               </a:solidFill>
               <a:effectLst/>
             </c:spPr>
@@ -197,7 +198,7 @@
                   <a:pPr>
                     <a:defRPr sz="1100" b="0" i="0" u="none" strike="noStrike">
                       <a:solidFill>
-                        <a:srgbClr val="1A2230"/>
+                        <a:srgbClr val="17251E"/>
                       </a:solidFill>
                       <a:latin typeface="Calibri"/>
                     </a:defRPr>
@@ -222,7 +223,7 @@
                   <a:pPr>
                     <a:defRPr sz="1100" b="0" i="0" u="none" strike="noStrike">
                       <a:solidFill>
-                        <a:srgbClr val="1A2230"/>
+                        <a:srgbClr val="17251E"/>
                       </a:solidFill>
                       <a:latin typeface="Calibri"/>
                     </a:defRPr>
@@ -247,7 +248,7 @@
                   <a:pPr>
                     <a:defRPr sz="1100" b="0" i="0" u="none" strike="noStrike">
                       <a:solidFill>
-                        <a:srgbClr val="1A2230"/>
+                        <a:srgbClr val="17251E"/>
                       </a:solidFill>
                       <a:latin typeface="Calibri"/>
                     </a:defRPr>
@@ -1005,7 +1006,7 @@
           <a:p>
             <a:r>
               <a:rPr lang="en-US" dirty="0"/>
-              <a:t>Close: DHAAL is explainable, private, and live today. The differentiator is intervention in the moment, in the citizen's language — a public-safety utility.</a:t>
+              <a:t/>
             </a:r>
             <a:endParaRPr lang="en-US" dirty="0"/>
           </a:p>
@@ -1029,6 +1030,94 @@
             <a:fld id="{F7021451-1387-4CA6-816F-3879F97B5CBC}" type="slidenum">
               <a:rPr lang="en-US"/>
               <a:t>12</a:t>
+            </a:fld>
+            <a:endParaRPr lang="en-US"/>
+          </a:p>
+        </p:txBody>
+      </p:sp>
+    </p:spTree>
+    <p:extLst>
+      <p:ext uri="{BB962C8B-B14F-4D97-AF65-F5344CB8AC3E}">
+        <p14:creationId xmlns:p14="http://schemas.microsoft.com/office/powerpoint/2010/main" val="1024086991"/>
+      </p:ext>
+    </p:extLst>
+  </p:cSld>
+  <p:clrMapOvr>
+    <a:masterClrMapping/>
+  </p:clrMapOvr>
+</p:notes>
+</file>
+
+<file path=ppt/notesSlides/notesSlide13.xml><?xml version="1.0" encoding="utf-8"?>
+<p:notes xmlns:a="http://schemas.openxmlformats.org/drawingml/2006/main" xmlns:r="http://schemas.openxmlformats.org/officeDocument/2006/relationships" xmlns:p="http://schemas.openxmlformats.org/presentationml/2006/main">
+  <p:cSld>
+    <p:spTree>
+      <p:nvGrpSpPr>
+        <p:cNvPr id="1" name=""/>
+        <p:cNvGrpSpPr/>
+        <p:nvPr/>
+      </p:nvGrpSpPr>
+      <p:grpSpPr>
+        <a:xfrm>
+          <a:off x="0" y="0"/>
+          <a:ext cx="0" cy="0"/>
+          <a:chOff x="0" y="0"/>
+          <a:chExt cx="0" cy="0"/>
+        </a:xfrm>
+      </p:grpSpPr>
+      <p:sp>
+        <p:nvSpPr>
+          <p:cNvPr id="2" name="Slide Image Placeholder 1"/>
+          <p:cNvSpPr>
+            <a:spLocks noGrp="1" noRot="1" noChangeAspect="1"/>
+          </p:cNvSpPr>
+          <p:nvPr>
+            <p:ph type="sldImg"/>
+          </p:nvPr>
+        </p:nvSpPr>
+        <p:spPr/>
+      </p:sp>
+      <p:sp>
+        <p:nvSpPr>
+          <p:cNvPr id="3" name="Notes Placeholder 2"/>
+          <p:cNvSpPr>
+            <a:spLocks noGrp="1"/>
+          </p:cNvSpPr>
+          <p:nvPr>
+            <p:ph type="body" idx="1"/>
+          </p:nvPr>
+        </p:nvSpPr>
+        <p:spPr/>
+        <p:txBody>
+          <a:bodyPr/>
+          <a:lstStyle/>
+          <a:p>
+            <a:r>
+              <a:rPr lang="en-US" dirty="0"/>
+              <a:t>Close: DHAAL is explainable, private, and live today. The differentiator is intervention in the moment, in the citizen's language — a public-safety utility.</a:t>
+            </a:r>
+            <a:endParaRPr lang="en-US" dirty="0"/>
+          </a:p>
+        </p:txBody>
+      </p:sp>
+      <p:sp>
+        <p:nvSpPr>
+          <p:cNvPr id="4" name="Slide Number Placeholder 3"/>
+          <p:cNvSpPr>
+            <a:spLocks noGrp="1"/>
+          </p:cNvSpPr>
+          <p:nvPr>
+            <p:ph type="sldNum" sz="quarter" idx="10"/>
+          </p:nvPr>
+        </p:nvSpPr>
+        <p:spPr/>
+        <p:txBody>
+          <a:bodyPr/>
+          <a:lstStyle/>
+          <a:p>
+            <a:fld id="{F7021451-1387-4CA6-816F-3879F97B5CBC}" type="slidenum">
+              <a:rPr lang="en-US"/>
+              <a:t>13</a:t>
             </a:fld>
             <a:endParaRPr lang="en-US"/>
           </a:p>
@@ -2064,7 +2153,7 @@
     <p:bg>
       <p:bgPr>
         <a:solidFill>
-          <a:srgbClr val="1F3864"/>
+          <a:srgbClr val="0E3D2C"/>
         </a:solidFill>
       </p:bgPr>
     </p:bg>
@@ -2097,7 +2186,7 @@
             <a:avLst/>
           </a:prstGeom>
           <a:solidFill>
-            <a:srgbClr val="2E5AA8"/>
+            <a:srgbClr val="1E8A5B"/>
           </a:solidFill>
           <a:ln/>
         </p:spPr>
@@ -2117,7 +2206,7 @@
             <a:avLst/>
           </a:prstGeom>
           <a:solidFill>
-            <a:srgbClr val="24406E"/>
+            <a:srgbClr val="0A2E22"/>
           </a:solidFill>
           <a:ln/>
         </p:spPr>
@@ -2178,7 +2267,7 @@
             <a:r>
               <a:rPr lang="en-US" sz="4000" b="1" dirty="0">
                 <a:solidFill>
-                  <a:srgbClr val="1F3864"/>
+                  <a:srgbClr val="0E3D2C"/>
                 </a:solidFill>
                 <a:latin typeface="Cambria" pitchFamily="34" charset="0"/>
                 <a:ea typeface="Cambria" pitchFamily="34" charset="-122"/>
@@ -2256,7 +2345,7 @@
             <a:r>
               <a:rPr lang="en-US" sz="2400" dirty="0">
                 <a:solidFill>
-                  <a:srgbClr val="CADCFC"/>
+                  <a:srgbClr val="CDE6D8"/>
                 </a:solidFill>
                 <a:latin typeface="Calibri" pitchFamily="34" charset="0"/>
                 <a:ea typeface="Calibri" pitchFamily="34" charset="-122"/>
@@ -2351,7 +2440,7 @@
             <a:r>
               <a:rPr lang="en-US" sz="1400" dirty="0">
                 <a:solidFill>
-                  <a:srgbClr val="CADCFC"/>
+                  <a:srgbClr val="CDE6D8"/>
                 </a:solidFill>
                 <a:latin typeface="Calibri" pitchFamily="34" charset="0"/>
                 <a:ea typeface="Calibri" pitchFamily="34" charset="-122"/>
@@ -2390,7 +2479,7 @@
             <a:r>
               <a:rPr lang="en-US" sz="1250" dirty="0">
                 <a:solidFill>
-                  <a:srgbClr val="9DB4E6"/>
+                  <a:srgbClr val="8FC9AD"/>
                 </a:solidFill>
                 <a:latin typeface="Calibri" pitchFamily="34" charset="0"/>
                 <a:ea typeface="Calibri" pitchFamily="34" charset="-122"/>
@@ -2461,7 +2550,7 @@
             <a:r>
               <a:rPr lang="en-US" sz="1250" b="1" spc="300" kern="0" dirty="0">
                 <a:solidFill>
-                  <a:srgbClr val="2E5AA8"/>
+                  <a:srgbClr val="1E8A5B"/>
                 </a:solidFill>
                 <a:latin typeface="Calibri" pitchFamily="34" charset="0"/>
                 <a:ea typeface="Calibri" pitchFamily="34" charset="-122"/>
@@ -2500,7 +2589,7 @@
             <a:r>
               <a:rPr lang="en-US" sz="3400" b="1" dirty="0">
                 <a:solidFill>
-                  <a:srgbClr val="1F3864"/>
+                  <a:srgbClr val="0E3D2C"/>
                 </a:solidFill>
                 <a:latin typeface="Cambria" pitchFamily="34" charset="0"/>
                 <a:ea typeface="Cambria" pitchFamily="34" charset="-122"/>
@@ -2533,7 +2622,7 @@
           </a:solidFill>
           <a:ln w="12700">
             <a:solidFill>
-              <a:srgbClr val="D8E0EE"/>
+              <a:srgbClr val="D3E4DA"/>
             </a:solidFill>
             <a:prstDash val="solid"/>
           </a:ln>
@@ -2573,7 +2662,7 @@
             <a:r>
               <a:rPr lang="en-US" sz="5200" b="1" dirty="0">
                 <a:solidFill>
-                  <a:srgbClr val="1F3864"/>
+                  <a:srgbClr val="0E3D2C"/>
                 </a:solidFill>
                 <a:latin typeface="Cambria" pitchFamily="34" charset="0"/>
                 <a:ea typeface="Cambria" pitchFamily="34" charset="-122"/>
@@ -2654,7 +2743,7 @@
             <a:r>
               <a:rPr lang="en-US" sz="1200" dirty="0">
                 <a:solidFill>
-                  <a:srgbClr val="5B6472"/>
+                  <a:srgbClr val="59665E"/>
                 </a:solidFill>
                 <a:latin typeface="Calibri" pitchFamily="34" charset="0"/>
                 <a:ea typeface="Calibri" pitchFamily="34" charset="-122"/>
@@ -2687,7 +2776,7 @@
           </a:solidFill>
           <a:ln w="12700">
             <a:solidFill>
-              <a:srgbClr val="D8E0EE"/>
+              <a:srgbClr val="D3E4DA"/>
             </a:solidFill>
             <a:prstDash val="solid"/>
           </a:ln>
@@ -2727,7 +2816,7 @@
             <a:r>
               <a:rPr lang="en-US" sz="5200" b="1" dirty="0">
                 <a:solidFill>
-                  <a:srgbClr val="1F3864"/>
+                  <a:srgbClr val="0E3D2C"/>
                 </a:solidFill>
                 <a:latin typeface="Cambria" pitchFamily="34" charset="0"/>
                 <a:ea typeface="Cambria" pitchFamily="34" charset="-122"/>
@@ -2808,7 +2897,7 @@
             <a:r>
               <a:rPr lang="en-US" sz="1200" dirty="0">
                 <a:solidFill>
-                  <a:srgbClr val="5B6472"/>
+                  <a:srgbClr val="59665E"/>
                 </a:solidFill>
                 <a:latin typeface="Calibri" pitchFamily="34" charset="0"/>
                 <a:ea typeface="Calibri" pitchFamily="34" charset="-122"/>
@@ -2841,7 +2930,7 @@
           </a:solidFill>
           <a:ln w="12700">
             <a:solidFill>
-              <a:srgbClr val="D8E0EE"/>
+              <a:srgbClr val="D3E4DA"/>
             </a:solidFill>
             <a:prstDash val="solid"/>
           </a:ln>
@@ -2881,7 +2970,7 @@
             <a:r>
               <a:rPr lang="en-US" sz="5200" b="1" dirty="0">
                 <a:solidFill>
-                  <a:srgbClr val="1F3864"/>
+                  <a:srgbClr val="0E3D2C"/>
                 </a:solidFill>
                 <a:latin typeface="Cambria" pitchFamily="34" charset="0"/>
                 <a:ea typeface="Cambria" pitchFamily="34" charset="-122"/>
@@ -2962,7 +3051,7 @@
             <a:r>
               <a:rPr lang="en-US" sz="1200" dirty="0">
                 <a:solidFill>
-                  <a:srgbClr val="5B6472"/>
+                  <a:srgbClr val="59665E"/>
                 </a:solidFill>
                 <a:latin typeface="Calibri" pitchFamily="34" charset="0"/>
                 <a:ea typeface="Calibri" pitchFamily="34" charset="-122"/>
@@ -2991,11 +3080,11 @@
             </a:avLst>
           </a:prstGeom>
           <a:solidFill>
-            <a:srgbClr val="1F3864"/>
+            <a:srgbClr val="0E3D2C"/>
           </a:solidFill>
           <a:ln w="12700">
             <a:solidFill>
-              <a:srgbClr val="D8E0EE"/>
+              <a:srgbClr val="D3E4DA"/>
             </a:solidFill>
             <a:prstDash val="solid"/>
           </a:ln>
@@ -3109,7 +3198,7 @@
             <a:r>
               <a:rPr lang="en-US" sz="1250" b="1" spc="300" kern="0" dirty="0">
                 <a:solidFill>
-                  <a:srgbClr val="2E5AA8"/>
+                  <a:srgbClr val="1E8A5B"/>
                 </a:solidFill>
                 <a:latin typeface="Calibri" pitchFamily="34" charset="0"/>
                 <a:ea typeface="Calibri" pitchFamily="34" charset="-122"/>
@@ -3148,7 +3237,7 @@
             <a:r>
               <a:rPr lang="en-US" sz="3400" b="1" dirty="0">
                 <a:solidFill>
-                  <a:srgbClr val="1F3864"/>
+                  <a:srgbClr val="0E3D2C"/>
                 </a:solidFill>
                 <a:latin typeface="Cambria" pitchFamily="34" charset="0"/>
                 <a:ea typeface="Cambria" pitchFamily="34" charset="-122"/>
@@ -3243,7 +3332,7 @@
           <a:noFill/>
           <a:ln w="25400">
             <a:solidFill>
-              <a:srgbClr val="D8E0EE"/>
+              <a:srgbClr val="D3E4DA"/>
             </a:solidFill>
             <a:prstDash val="dash"/>
           </a:ln>
@@ -3315,7 +3404,7 @@
             <a:r>
               <a:rPr lang="en-US" sz="1600" b="1" dirty="0">
                 <a:solidFill>
-                  <a:srgbClr val="1F3864"/>
+                  <a:srgbClr val="0E3D2C"/>
                 </a:solidFill>
                 <a:latin typeface="Cambria" pitchFamily="34" charset="0"/>
                 <a:ea typeface="Cambria" pitchFamily="34" charset="-122"/>
@@ -3357,7 +3446,7 @@
             <a:r>
               <a:rPr lang="en-US" sz="1200" dirty="0">
                 <a:solidFill>
-                  <a:srgbClr val="5B6472"/>
+                  <a:srgbClr val="59665E"/>
                 </a:solidFill>
                 <a:latin typeface="Calibri" pitchFamily="34" charset="0"/>
                 <a:ea typeface="Calibri" pitchFamily="34" charset="-122"/>
@@ -3384,7 +3473,7 @@
             <a:avLst/>
           </a:prstGeom>
           <a:solidFill>
-            <a:srgbClr val="2E5AA8"/>
+            <a:srgbClr val="1E8A5B"/>
           </a:solidFill>
           <a:ln/>
           <a:effectLst>
@@ -3452,7 +3541,7 @@
           <a:noFill/>
           <a:ln w="25400">
             <a:solidFill>
-              <a:srgbClr val="D8E0EE"/>
+              <a:srgbClr val="D3E4DA"/>
             </a:solidFill>
             <a:prstDash val="dash"/>
           </a:ln>
@@ -3485,7 +3574,7 @@
             <a:r>
               <a:rPr lang="en-US" sz="1200" b="1" spc="200" kern="0" dirty="0">
                 <a:solidFill>
-                  <a:srgbClr val="2E5AA8"/>
+                  <a:srgbClr val="1E8A5B"/>
                 </a:solidFill>
                 <a:latin typeface="Calibri" pitchFamily="34" charset="0"/>
                 <a:ea typeface="Calibri" pitchFamily="34" charset="-122"/>
@@ -3524,7 +3613,7 @@
             <a:r>
               <a:rPr lang="en-US" sz="1600" b="1" dirty="0">
                 <a:solidFill>
-                  <a:srgbClr val="1F3864"/>
+                  <a:srgbClr val="0E3D2C"/>
                 </a:solidFill>
                 <a:latin typeface="Cambria" pitchFamily="34" charset="0"/>
                 <a:ea typeface="Cambria" pitchFamily="34" charset="-122"/>
@@ -3566,7 +3655,7 @@
             <a:r>
               <a:rPr lang="en-US" sz="1200" dirty="0">
                 <a:solidFill>
-                  <a:srgbClr val="5B6472"/>
+                  <a:srgbClr val="59665E"/>
                 </a:solidFill>
                 <a:latin typeface="Calibri" pitchFamily="34" charset="0"/>
                 <a:ea typeface="Calibri" pitchFamily="34" charset="-122"/>
@@ -3593,7 +3682,7 @@
             <a:avLst/>
           </a:prstGeom>
           <a:solidFill>
-            <a:srgbClr val="1F3864"/>
+            <a:srgbClr val="0E3D2C"/>
           </a:solidFill>
           <a:ln/>
           <a:effectLst>
@@ -3661,7 +3750,7 @@
           <a:noFill/>
           <a:ln w="25400">
             <a:solidFill>
-              <a:srgbClr val="D8E0EE"/>
+              <a:srgbClr val="D3E4DA"/>
             </a:solidFill>
             <a:prstDash val="dash"/>
           </a:ln>
@@ -3694,7 +3783,7 @@
             <a:r>
               <a:rPr lang="en-US" sz="1200" b="1" spc="200" kern="0" dirty="0">
                 <a:solidFill>
-                  <a:srgbClr val="1F3864"/>
+                  <a:srgbClr val="0E3D2C"/>
                 </a:solidFill>
                 <a:latin typeface="Calibri" pitchFamily="34" charset="0"/>
                 <a:ea typeface="Calibri" pitchFamily="34" charset="-122"/>
@@ -3733,7 +3822,7 @@
             <a:r>
               <a:rPr lang="en-US" sz="1600" b="1" dirty="0">
                 <a:solidFill>
-                  <a:srgbClr val="1F3864"/>
+                  <a:srgbClr val="0E3D2C"/>
                 </a:solidFill>
                 <a:latin typeface="Cambria" pitchFamily="34" charset="0"/>
                 <a:ea typeface="Cambria" pitchFamily="34" charset="-122"/>
@@ -3775,7 +3864,7 @@
             <a:r>
               <a:rPr lang="en-US" sz="1200" dirty="0">
                 <a:solidFill>
-                  <a:srgbClr val="5B6472"/>
+                  <a:srgbClr val="59665E"/>
                 </a:solidFill>
                 <a:latin typeface="Calibri" pitchFamily="34" charset="0"/>
                 <a:ea typeface="Calibri" pitchFamily="34" charset="-122"/>
@@ -3841,7 +3930,7 @@
             <a:r>
               <a:rPr lang="en-US" sz="2000" b="1" dirty="0">
                 <a:solidFill>
-                  <a:srgbClr val="1F3864"/>
+                  <a:srgbClr val="0E3D2C"/>
                 </a:solidFill>
                 <a:latin typeface="Cambria" pitchFamily="34" charset="0"/>
                 <a:ea typeface="Cambria" pitchFamily="34" charset="-122"/>
@@ -3919,7 +4008,7 @@
             <a:r>
               <a:rPr lang="en-US" sz="1600" b="1" dirty="0">
                 <a:solidFill>
-                  <a:srgbClr val="1F3864"/>
+                  <a:srgbClr val="0E3D2C"/>
                 </a:solidFill>
                 <a:latin typeface="Cambria" pitchFamily="34" charset="0"/>
                 <a:ea typeface="Cambria" pitchFamily="34" charset="-122"/>
@@ -3961,7 +4050,7 @@
             <a:r>
               <a:rPr lang="en-US" sz="1200" dirty="0">
                 <a:solidFill>
-                  <a:srgbClr val="5B6472"/>
+                  <a:srgbClr val="59665E"/>
                 </a:solidFill>
                 <a:latin typeface="Calibri" pitchFamily="34" charset="0"/>
                 <a:ea typeface="Calibri" pitchFamily="34" charset="-122"/>
@@ -3990,11 +4079,11 @@
             </a:avLst>
           </a:prstGeom>
           <a:solidFill>
-            <a:srgbClr val="EAF0FB"/>
+            <a:srgbClr val="EEF6F0"/>
           </a:solidFill>
           <a:ln w="12700">
             <a:solidFill>
-              <a:srgbClr val="D8E0EE"/>
+              <a:srgbClr val="D3E4DA"/>
             </a:solidFill>
             <a:prstDash val="solid"/>
           </a:ln>
@@ -4034,7 +4123,7 @@
             <a:r>
               <a:rPr lang="en-US" sz="1350" b="1" dirty="0">
                 <a:solidFill>
-                  <a:srgbClr val="1F3864"/>
+                  <a:srgbClr val="0E3D2C"/>
                 </a:solidFill>
                 <a:latin typeface="Calibri" pitchFamily="34" charset="0"/>
                 <a:ea typeface="Calibri" pitchFamily="34" charset="-122"/>
@@ -4048,7 +4137,7 @@
             <a:r>
               <a:rPr lang="en-US" sz="1350" dirty="0">
                 <a:solidFill>
-                  <a:srgbClr val="1A2230"/>
+                  <a:srgbClr val="17251E"/>
                 </a:solidFill>
                 <a:latin typeface="Calibri" pitchFamily="34" charset="0"/>
                 <a:ea typeface="Calibri" pitchFamily="34" charset="-122"/>
@@ -4074,7 +4163,7 @@
     <p:bg>
       <p:bgPr>
         <a:solidFill>
-          <a:srgbClr val="1F3864"/>
+          <a:srgbClr val="FFFFFF"/>
         </a:solidFill>
       </p:bgPr>
     </p:bg>
@@ -4094,6 +4183,392 @@
       </p:grpSpPr>
       <p:sp>
         <p:nvSpPr>
+          <p:cNvPr id="2" name="Text 0"/>
+          <p:cNvSpPr/>
+          <p:nvPr/>
+        </p:nvSpPr>
+        <p:spPr>
+          <a:xfrm>
+            <a:off x="640080" y="502920"/>
+            <a:ext cx="10058400" cy="292608"/>
+          </a:xfrm>
+          <a:prstGeom prst="rect">
+            <a:avLst/>
+          </a:prstGeom>
+          <a:noFill/>
+          <a:ln/>
+        </p:spPr>
+        <p:txBody>
+          <a:bodyPr wrap="square" lIns="0" tIns="0" rIns="0" bIns="0" rtlCol="0" anchor="ctr"/>
+          <a:lstStyle/>
+          <a:p>
+            <a:pPr indent="0" marL="0">
+              <a:buNone/>
+            </a:pPr>
+            <a:r>
+              <a:rPr lang="en-US" sz="1250" b="1" spc="300" kern="0" dirty="0">
+                <a:solidFill>
+                  <a:srgbClr val="1E8A5B"/>
+                </a:solidFill>
+                <a:latin typeface="Calibri" pitchFamily="34" charset="0"/>
+                <a:ea typeface="Calibri" pitchFamily="34" charset="-122"/>
+                <a:cs typeface="Calibri" pitchFamily="34" charset="-120"/>
+              </a:rPr>
+              <a:t>THE TEAM</a:t>
+            </a:r>
+            <a:endParaRPr lang="en-US" sz="1250" dirty="0"/>
+          </a:p>
+        </p:txBody>
+      </p:sp>
+      <p:sp>
+        <p:nvSpPr>
+          <p:cNvPr id="3" name="Text 1"/>
+          <p:cNvSpPr/>
+          <p:nvPr/>
+        </p:nvSpPr>
+        <p:spPr>
+          <a:xfrm>
+            <a:off x="640080" y="822960"/>
+            <a:ext cx="10972800" cy="822960"/>
+          </a:xfrm>
+          <a:prstGeom prst="rect">
+            <a:avLst/>
+          </a:prstGeom>
+          <a:noFill/>
+          <a:ln/>
+        </p:spPr>
+        <p:txBody>
+          <a:bodyPr wrap="square" lIns="0" tIns="0" rIns="0" bIns="0" rtlCol="0" anchor="ctr"/>
+          <a:lstStyle/>
+          <a:p>
+            <a:pPr indent="0" marL="0">
+              <a:buNone/>
+            </a:pPr>
+            <a:r>
+              <a:rPr lang="en-US" sz="3400" b="1" dirty="0">
+                <a:solidFill>
+                  <a:srgbClr val="0E3D2C"/>
+                </a:solidFill>
+                <a:latin typeface="Cambria" pitchFamily="34" charset="0"/>
+                <a:ea typeface="Cambria" pitchFamily="34" charset="-122"/>
+                <a:cs typeface="Cambria" pitchFamily="34" charset="-120"/>
+              </a:rPr>
+              <a:t>Team DHAAL</a:t>
+            </a:r>
+            <a:endParaRPr lang="en-US" sz="3400" dirty="0"/>
+          </a:p>
+        </p:txBody>
+      </p:sp>
+      <p:pic>
+        <p:nvPicPr>
+          <p:cNvPr id="4" name="Image 0" descr="/home/claude/dhaal/deck/aditya.jpg">    </p:cNvPr>
+          <p:cNvPicPr>
+            <a:picLocks noChangeAspect="1"/>
+          </p:cNvPicPr>
+          <p:nvPr/>
+        </p:nvPicPr>
+        <p:blipFill>
+          <a:blip r:embed="rId1"/>
+          <a:stretch>
+            <a:fillRect/>
+          </a:stretch>
+        </p:blipFill>
+        <p:spPr>
+          <a:xfrm>
+            <a:off x="3246120" y="1874520"/>
+            <a:ext cx="2377440" cy="2377440"/>
+          </a:xfrm>
+          <a:prstGeom prst="ellipse">
+            <a:avLst/>
+          </a:prstGeom>
+          <a:effectLst>
+            <a:outerShdw sx="100000" sy="100000" kx="0" ky="0" algn="bl" rotWithShape="0" blurRad="127000" dist="50800" dir="5400000">
+              <a:srgbClr val="C7D0E0">
+                <a:alpha val="50000"/>
+              </a:srgbClr>
+            </a:outerShdw>
+          </a:effectLst>
+        </p:spPr>
+      </p:pic>
+      <p:sp>
+        <p:nvSpPr>
+          <p:cNvPr id="5" name="Shape 2"/>
+          <p:cNvSpPr/>
+          <p:nvPr/>
+        </p:nvSpPr>
+        <p:spPr>
+          <a:xfrm>
+            <a:off x="2926080" y="4526280"/>
+            <a:ext cx="3017520" cy="566928"/>
+          </a:xfrm>
+          <a:prstGeom prst="roundRect">
+            <a:avLst>
+              <a:gd name="adj" fmla="val 16129"/>
+            </a:avLst>
+          </a:prstGeom>
+          <a:solidFill>
+            <a:srgbClr val="0E3D2C"/>
+          </a:solidFill>
+          <a:ln/>
+          <a:effectLst>
+            <a:outerShdw sx="100000" sy="100000" kx="0" ky="0" algn="bl" rotWithShape="0" blurRad="127000" dist="50800" dir="5400000">
+              <a:srgbClr val="C7D0E0">
+                <a:alpha val="50000"/>
+              </a:srgbClr>
+            </a:outerShdw>
+          </a:effectLst>
+        </p:spPr>
+      </p:sp>
+      <p:sp>
+        <p:nvSpPr>
+          <p:cNvPr id="6" name="Text 3"/>
+          <p:cNvSpPr/>
+          <p:nvPr/>
+        </p:nvSpPr>
+        <p:spPr>
+          <a:xfrm>
+            <a:off x="2926080" y="4526280"/>
+            <a:ext cx="3017520" cy="566928"/>
+          </a:xfrm>
+          <a:prstGeom prst="rect">
+            <a:avLst/>
+          </a:prstGeom>
+          <a:noFill/>
+          <a:ln/>
+        </p:spPr>
+        <p:txBody>
+          <a:bodyPr wrap="square" lIns="0" tIns="0" rIns="0" bIns="0" rtlCol="0" anchor="ctr"/>
+          <a:lstStyle/>
+          <a:p>
+            <a:pPr algn="ctr" indent="0" marL="0">
+              <a:buNone/>
+            </a:pPr>
+            <a:r>
+              <a:rPr lang="en-US" sz="1700" b="1" dirty="0">
+                <a:solidFill>
+                  <a:srgbClr val="FFFFFF"/>
+                </a:solidFill>
+                <a:latin typeface="Cambria" pitchFamily="34" charset="0"/>
+                <a:ea typeface="Cambria" pitchFamily="34" charset="-122"/>
+                <a:cs typeface="Cambria" pitchFamily="34" charset="-120"/>
+              </a:rPr>
+              <a:t>Aditya Gupta</a:t>
+            </a:r>
+            <a:endParaRPr lang="en-US" sz="1700" dirty="0"/>
+          </a:p>
+        </p:txBody>
+      </p:sp>
+      <p:pic>
+        <p:nvPicPr>
+          <p:cNvPr id="7" name="Image 1" descr="/home/claude/dhaal/deck/gaurav.jpg">    </p:cNvPr>
+          <p:cNvPicPr>
+            <a:picLocks noChangeAspect="1"/>
+          </p:cNvPicPr>
+          <p:nvPr/>
+        </p:nvPicPr>
+        <p:blipFill>
+          <a:blip r:embed="rId2"/>
+          <a:stretch>
+            <a:fillRect/>
+          </a:stretch>
+        </p:blipFill>
+        <p:spPr>
+          <a:xfrm>
+            <a:off x="6565392" y="1874520"/>
+            <a:ext cx="2377440" cy="2377440"/>
+          </a:xfrm>
+          <a:prstGeom prst="ellipse">
+            <a:avLst/>
+          </a:prstGeom>
+          <a:effectLst>
+            <a:outerShdw sx="100000" sy="100000" kx="0" ky="0" algn="bl" rotWithShape="0" blurRad="127000" dist="50800" dir="5400000">
+              <a:srgbClr val="C7D0E0">
+                <a:alpha val="50000"/>
+              </a:srgbClr>
+            </a:outerShdw>
+          </a:effectLst>
+        </p:spPr>
+      </p:pic>
+      <p:sp>
+        <p:nvSpPr>
+          <p:cNvPr id="8" name="Shape 4"/>
+          <p:cNvSpPr/>
+          <p:nvPr/>
+        </p:nvSpPr>
+        <p:spPr>
+          <a:xfrm>
+            <a:off x="6245352" y="4526280"/>
+            <a:ext cx="3017520" cy="566928"/>
+          </a:xfrm>
+          <a:prstGeom prst="roundRect">
+            <a:avLst>
+              <a:gd name="adj" fmla="val 16129"/>
+            </a:avLst>
+          </a:prstGeom>
+          <a:solidFill>
+            <a:srgbClr val="0E3D2C"/>
+          </a:solidFill>
+          <a:ln/>
+          <a:effectLst>
+            <a:outerShdw sx="100000" sy="100000" kx="0" ky="0" algn="bl" rotWithShape="0" blurRad="127000" dist="50800" dir="5400000">
+              <a:srgbClr val="C7D0E0">
+                <a:alpha val="50000"/>
+              </a:srgbClr>
+            </a:outerShdw>
+          </a:effectLst>
+        </p:spPr>
+      </p:sp>
+      <p:sp>
+        <p:nvSpPr>
+          <p:cNvPr id="9" name="Text 5"/>
+          <p:cNvSpPr/>
+          <p:nvPr/>
+        </p:nvSpPr>
+        <p:spPr>
+          <a:xfrm>
+            <a:off x="6245352" y="4526280"/>
+            <a:ext cx="3017520" cy="566928"/>
+          </a:xfrm>
+          <a:prstGeom prst="rect">
+            <a:avLst/>
+          </a:prstGeom>
+          <a:noFill/>
+          <a:ln/>
+        </p:spPr>
+        <p:txBody>
+          <a:bodyPr wrap="square" lIns="0" tIns="0" rIns="0" bIns="0" rtlCol="0" anchor="ctr"/>
+          <a:lstStyle/>
+          <a:p>
+            <a:pPr algn="ctr" indent="0" marL="0">
+              <a:buNone/>
+            </a:pPr>
+            <a:r>
+              <a:rPr lang="en-US" sz="1700" b="1" dirty="0">
+                <a:solidFill>
+                  <a:srgbClr val="FFFFFF"/>
+                </a:solidFill>
+                <a:latin typeface="Cambria" pitchFamily="34" charset="0"/>
+                <a:ea typeface="Cambria" pitchFamily="34" charset="-122"/>
+                <a:cs typeface="Cambria" pitchFamily="34" charset="-120"/>
+              </a:rPr>
+              <a:t>Gaurav Vishwakarma</a:t>
+            </a:r>
+            <a:endParaRPr lang="en-US" sz="1700" dirty="0"/>
+          </a:p>
+        </p:txBody>
+      </p:sp>
+      <p:sp>
+        <p:nvSpPr>
+          <p:cNvPr id="10" name="Text 6"/>
+          <p:cNvSpPr/>
+          <p:nvPr/>
+        </p:nvSpPr>
+        <p:spPr>
+          <a:xfrm>
+            <a:off x="640080" y="5532120"/>
+            <a:ext cx="10972800" cy="365760"/>
+          </a:xfrm>
+          <a:prstGeom prst="rect">
+            <a:avLst/>
+          </a:prstGeom>
+          <a:noFill/>
+          <a:ln/>
+        </p:spPr>
+        <p:txBody>
+          <a:bodyPr wrap="square" lIns="0" tIns="0" rIns="0" bIns="0" rtlCol="0" anchor="ctr"/>
+          <a:lstStyle/>
+          <a:p>
+            <a:pPr algn="ctr" indent="0" marL="0">
+              <a:buNone/>
+            </a:pPr>
+            <a:r>
+              <a:rPr lang="en-US" sz="1250" i="1" dirty="0">
+                <a:solidFill>
+                  <a:srgbClr val="59665E"/>
+                </a:solidFill>
+                <a:latin typeface="Calibri" pitchFamily="34" charset="0"/>
+                <a:ea typeface="Calibri" pitchFamily="34" charset="-122"/>
+                <a:cs typeface="Calibri" pitchFamily="34" charset="-120"/>
+              </a:rPr>
+              <a:t>Two builders · one shield — an explainable, privacy-first AI defence against digital-arrest &amp; UPI fraud.</a:t>
+            </a:r>
+            <a:endParaRPr lang="en-US" sz="1250" dirty="0"/>
+          </a:p>
+        </p:txBody>
+      </p:sp>
+      <p:sp>
+        <p:nvSpPr>
+          <p:cNvPr id="11" name="Text 7"/>
+          <p:cNvSpPr/>
+          <p:nvPr/>
+        </p:nvSpPr>
+        <p:spPr>
+          <a:xfrm>
+            <a:off x="640080" y="5943600"/>
+            <a:ext cx="10972800" cy="320040"/>
+          </a:xfrm>
+          <a:prstGeom prst="rect">
+            <a:avLst/>
+          </a:prstGeom>
+          <a:noFill/>
+          <a:ln/>
+        </p:spPr>
+        <p:txBody>
+          <a:bodyPr wrap="square" lIns="0" tIns="0" rIns="0" bIns="0" rtlCol="0" anchor="ctr"/>
+          <a:lstStyle/>
+          <a:p>
+            <a:pPr algn="ctr" indent="0" marL="0">
+              <a:buNone/>
+            </a:pPr>
+            <a:r>
+              <a:rPr lang="en-US" sz="1150" b="1" spc="100" kern="0" dirty="0">
+                <a:solidFill>
+                  <a:srgbClr val="1E8A5B"/>
+                </a:solidFill>
+                <a:latin typeface="Calibri" pitchFamily="34" charset="0"/>
+                <a:ea typeface="Calibri" pitchFamily="34" charset="-122"/>
+                <a:cs typeface="Calibri" pitchFamily="34" charset="-120"/>
+              </a:rPr>
+              <a:t>ET AI Hackathon 2.0  ·  PS-6 · AI for Digital Public Safety</a:t>
+            </a:r>
+            <a:endParaRPr lang="en-US" sz="1150" dirty="0"/>
+          </a:p>
+        </p:txBody>
+      </p:sp>
+    </p:spTree>
+  </p:cSld>
+  <p:clrMapOvr>
+    <a:masterClrMapping/>
+  </p:clrMapOvr>
+</p:sld>
+</file>
+
+<file path=ppt/slides/slide13.xml><?xml version="1.0" encoding="utf-8"?>
+<p:sld xmlns:a="http://schemas.openxmlformats.org/drawingml/2006/main" xmlns:r="http://schemas.openxmlformats.org/officeDocument/2006/relationships" xmlns:p="http://schemas.openxmlformats.org/presentationml/2006/main">
+  <p:cSld name="Slide 13">
+    <p:bg>
+      <p:bgPr>
+        <a:solidFill>
+          <a:srgbClr val="0E3D2C"/>
+        </a:solidFill>
+      </p:bgPr>
+    </p:bg>
+    <p:spTree>
+      <p:nvGrpSpPr>
+        <p:cNvPr id="1" name=""/>
+        <p:cNvGrpSpPr/>
+        <p:nvPr/>
+      </p:nvGrpSpPr>
+      <p:grpSpPr>
+        <a:xfrm>
+          <a:off x="0" y="0"/>
+          <a:ext cx="0" cy="0"/>
+          <a:chOff x="0" y="0"/>
+          <a:chExt cx="0" cy="0"/>
+        </a:xfrm>
+      </p:grpSpPr>
+      <p:sp>
+        <p:nvSpPr>
           <p:cNvPr id="2" name="Shape 0"/>
           <p:cNvSpPr/>
           <p:nvPr/>
@@ -4107,7 +4582,7 @@
             <a:avLst/>
           </a:prstGeom>
           <a:solidFill>
-            <a:srgbClr val="24406E"/>
+            <a:srgbClr val="0A2E22"/>
           </a:solidFill>
           <a:ln/>
         </p:spPr>
@@ -4127,7 +4602,7 @@
             <a:avLst/>
           </a:prstGeom>
           <a:solidFill>
-            <a:srgbClr val="2E5AA8"/>
+            <a:srgbClr val="1E8A5B"/>
           </a:solidFill>
           <a:ln/>
         </p:spPr>
@@ -4181,7 +4656,7 @@
             <a:r>
               <a:rPr lang="en-US" sz="3600" b="1" dirty="0">
                 <a:solidFill>
-                  <a:srgbClr val="1F3864"/>
+                  <a:srgbClr val="0E3D2C"/>
                 </a:solidFill>
                 <a:latin typeface="Cambria" pitchFamily="34" charset="0"/>
                 <a:ea typeface="Cambria" pitchFamily="34" charset="-122"/>
@@ -4311,7 +4786,7 @@
             </a:avLst>
           </a:prstGeom>
           <a:solidFill>
-            <a:srgbClr val="294574"/>
+            <a:srgbClr val="12503A"/>
           </a:solidFill>
           <a:ln/>
         </p:spPr>
@@ -4411,7 +4886,7 @@
             </a:avLst>
           </a:prstGeom>
           <a:solidFill>
-            <a:srgbClr val="294574"/>
+            <a:srgbClr val="12503A"/>
           </a:solidFill>
           <a:ln/>
         </p:spPr>
@@ -4511,7 +4986,7 @@
             </a:avLst>
           </a:prstGeom>
           <a:solidFill>
-            <a:srgbClr val="294574"/>
+            <a:srgbClr val="12503A"/>
           </a:solidFill>
           <a:ln/>
         </p:spPr>
@@ -4621,7 +5096,7 @@
             <a:r>
               <a:rPr lang="en-US" sz="1200" dirty="0">
                 <a:solidFill>
-                  <a:srgbClr val="9DB4E6"/>
+                  <a:srgbClr val="8FC9AD"/>
                 </a:solidFill>
                 <a:latin typeface="Calibri" pitchFamily="34" charset="0"/>
                 <a:ea typeface="Calibri" pitchFamily="34" charset="-122"/>
@@ -4692,7 +5167,7 @@
             <a:r>
               <a:rPr lang="en-US" sz="1250" b="1" spc="300" kern="0" dirty="0">
                 <a:solidFill>
-                  <a:srgbClr val="2E5AA8"/>
+                  <a:srgbClr val="1E8A5B"/>
                 </a:solidFill>
                 <a:latin typeface="Calibri" pitchFamily="34" charset="0"/>
                 <a:ea typeface="Calibri" pitchFamily="34" charset="-122"/>
@@ -4731,7 +5206,7 @@
             <a:r>
               <a:rPr lang="en-US" sz="3400" b="1" dirty="0">
                 <a:solidFill>
-                  <a:srgbClr val="1F3864"/>
+                  <a:srgbClr val="0E3D2C"/>
                 </a:solidFill>
                 <a:latin typeface="Cambria" pitchFamily="34" charset="0"/>
                 <a:ea typeface="Cambria" pitchFamily="34" charset="-122"/>
@@ -4760,11 +5235,11 @@
             </a:avLst>
           </a:prstGeom>
           <a:solidFill>
-            <a:srgbClr val="1F3864"/>
+            <a:srgbClr val="0E3D2C"/>
           </a:solidFill>
           <a:ln w="12700">
             <a:solidFill>
-              <a:srgbClr val="D8E0EE"/>
+              <a:srgbClr val="D3E4DA"/>
             </a:solidFill>
             <a:prstDash val="solid"/>
           </a:ln>
@@ -4885,7 +5360,7 @@
             <a:r>
               <a:rPr lang="en-US" sz="1550" dirty="0">
                 <a:solidFill>
-                  <a:srgbClr val="CADCFC"/>
+                  <a:srgbClr val="CDE6D8"/>
                 </a:solidFill>
                 <a:latin typeface="Calibri" pitchFamily="34" charset="0"/>
                 <a:ea typeface="Calibri" pitchFamily="34" charset="-122"/>
@@ -4924,7 +5399,7 @@
             <a:r>
               <a:rPr lang="en-US" sz="1050" i="1" dirty="0">
                 <a:solidFill>
-                  <a:srgbClr val="9DB4E6"/>
+                  <a:srgbClr val="8FC9AD"/>
                 </a:solidFill>
                 <a:latin typeface="Calibri" pitchFamily="34" charset="0"/>
                 <a:ea typeface="Calibri" pitchFamily="34" charset="-122"/>
@@ -4957,7 +5432,7 @@
           </a:solidFill>
           <a:ln w="12700">
             <a:solidFill>
-              <a:srgbClr val="D8E0EE"/>
+              <a:srgbClr val="D3E4DA"/>
             </a:solidFill>
             <a:prstDash val="solid"/>
           </a:ln>
@@ -4997,7 +5472,7 @@
             <a:r>
               <a:rPr lang="en-US" sz="1400" b="1" dirty="0">
                 <a:solidFill>
-                  <a:srgbClr val="1A2230"/>
+                  <a:srgbClr val="17251E"/>
                 </a:solidFill>
                 <a:latin typeface="Calibri" pitchFamily="34" charset="0"/>
                 <a:ea typeface="Calibri" pitchFamily="34" charset="-122"/>
@@ -5040,7 +5515,7 @@
             <a:avLst/>
           </a:prstGeom>
           <a:solidFill>
-            <a:srgbClr val="2E5AA8"/>
+            <a:srgbClr val="1E8A5B"/>
           </a:solidFill>
           <a:ln/>
         </p:spPr>
@@ -5072,7 +5547,7 @@
             <a:r>
               <a:rPr lang="en-US" sz="1150" b="1" dirty="0">
                 <a:solidFill>
-                  <a:srgbClr val="1A2230"/>
+                  <a:srgbClr val="17251E"/>
                 </a:solidFill>
                 <a:latin typeface="Calibri" pitchFamily="34" charset="0"/>
                 <a:ea typeface="Calibri" pitchFamily="34" charset="-122"/>
@@ -5111,7 +5586,7 @@
             <a:r>
               <a:rPr lang="en-US" sz="1050" dirty="0">
                 <a:solidFill>
-                  <a:srgbClr val="5B6472"/>
+                  <a:srgbClr val="59665E"/>
                 </a:solidFill>
                 <a:latin typeface="Calibri" pitchFamily="34" charset="0"/>
                 <a:ea typeface="Calibri" pitchFamily="34" charset="-122"/>
@@ -5170,7 +5645,7 @@
             <a:r>
               <a:rPr lang="en-US" sz="1150" b="1" dirty="0">
                 <a:solidFill>
-                  <a:srgbClr val="1A2230"/>
+                  <a:srgbClr val="17251E"/>
                 </a:solidFill>
                 <a:latin typeface="Calibri" pitchFamily="34" charset="0"/>
                 <a:ea typeface="Calibri" pitchFamily="34" charset="-122"/>
@@ -5209,7 +5684,7 @@
             <a:r>
               <a:rPr lang="en-US" sz="1050" dirty="0">
                 <a:solidFill>
-                  <a:srgbClr val="5B6472"/>
+                  <a:srgbClr val="59665E"/>
                 </a:solidFill>
                 <a:latin typeface="Calibri" pitchFamily="34" charset="0"/>
                 <a:ea typeface="Calibri" pitchFamily="34" charset="-122"/>
@@ -5236,7 +5711,7 @@
             <a:avLst/>
           </a:prstGeom>
           <a:solidFill>
-            <a:srgbClr val="CADCFC"/>
+            <a:srgbClr val="CDE6D8"/>
           </a:solidFill>
           <a:ln/>
         </p:spPr>
@@ -5268,7 +5743,7 @@
             <a:r>
               <a:rPr lang="en-US" sz="1150" b="1" dirty="0">
                 <a:solidFill>
-                  <a:srgbClr val="1A2230"/>
+                  <a:srgbClr val="17251E"/>
                 </a:solidFill>
                 <a:latin typeface="Calibri" pitchFamily="34" charset="0"/>
                 <a:ea typeface="Calibri" pitchFamily="34" charset="-122"/>
@@ -5307,7 +5782,7 @@
             <a:r>
               <a:rPr lang="en-US" sz="1050" dirty="0">
                 <a:solidFill>
-                  <a:srgbClr val="5B6472"/>
+                  <a:srgbClr val="59665E"/>
                 </a:solidFill>
                 <a:latin typeface="Calibri" pitchFamily="34" charset="0"/>
                 <a:ea typeface="Calibri" pitchFamily="34" charset="-122"/>
@@ -5417,7 +5892,7 @@
             <a:r>
               <a:rPr lang="en-US" sz="1250" b="1" spc="300" kern="0" dirty="0">
                 <a:solidFill>
-                  <a:srgbClr val="2E5AA8"/>
+                  <a:srgbClr val="1E8A5B"/>
                 </a:solidFill>
                 <a:latin typeface="Calibri" pitchFamily="34" charset="0"/>
                 <a:ea typeface="Calibri" pitchFamily="34" charset="-122"/>
@@ -5456,7 +5931,7 @@
             <a:r>
               <a:rPr lang="en-US" sz="3400" b="1" dirty="0">
                 <a:solidFill>
-                  <a:srgbClr val="1F3864"/>
+                  <a:srgbClr val="0E3D2C"/>
                 </a:solidFill>
                 <a:latin typeface="Cambria" pitchFamily="34" charset="0"/>
                 <a:ea typeface="Cambria" pitchFamily="34" charset="-122"/>
@@ -5489,7 +5964,7 @@
           </a:solidFill>
           <a:ln w="12700">
             <a:solidFill>
-              <a:srgbClr val="D8E0EE"/>
+              <a:srgbClr val="D3E4DA"/>
             </a:solidFill>
             <a:prstDash val="solid"/>
           </a:ln>
@@ -5595,7 +6070,7 @@
             <a:r>
               <a:rPr lang="en-US" sz="1850" b="1" dirty="0">
                 <a:solidFill>
-                  <a:srgbClr val="1F3864"/>
+                  <a:srgbClr val="0E3D2C"/>
                 </a:solidFill>
                 <a:latin typeface="Cambria" pitchFamily="34" charset="0"/>
                 <a:ea typeface="Cambria" pitchFamily="34" charset="-122"/>
@@ -5637,7 +6112,7 @@
             <a:r>
               <a:rPr lang="en-US" sz="1350" dirty="0">
                 <a:solidFill>
-                  <a:srgbClr val="5B6472"/>
+                  <a:srgbClr val="59665E"/>
                 </a:solidFill>
                 <a:latin typeface="Calibri" pitchFamily="34" charset="0"/>
                 <a:ea typeface="Calibri" pitchFamily="34" charset="-122"/>
@@ -5670,7 +6145,7 @@
           </a:solidFill>
           <a:ln w="12700">
             <a:solidFill>
-              <a:srgbClr val="D8E0EE"/>
+              <a:srgbClr val="D3E4DA"/>
             </a:solidFill>
             <a:prstDash val="solid"/>
           </a:ln>
@@ -5776,7 +6251,7 @@
             <a:r>
               <a:rPr lang="en-US" sz="1850" b="1" dirty="0">
                 <a:solidFill>
-                  <a:srgbClr val="1F3864"/>
+                  <a:srgbClr val="0E3D2C"/>
                 </a:solidFill>
                 <a:latin typeface="Cambria" pitchFamily="34" charset="0"/>
                 <a:ea typeface="Cambria" pitchFamily="34" charset="-122"/>
@@ -5818,7 +6293,7 @@
             <a:r>
               <a:rPr lang="en-US" sz="1350" dirty="0">
                 <a:solidFill>
-                  <a:srgbClr val="5B6472"/>
+                  <a:srgbClr val="59665E"/>
                 </a:solidFill>
                 <a:latin typeface="Calibri" pitchFamily="34" charset="0"/>
                 <a:ea typeface="Calibri" pitchFamily="34" charset="-122"/>
@@ -5851,7 +6326,7 @@
           </a:solidFill>
           <a:ln w="12700">
             <a:solidFill>
-              <a:srgbClr val="D8E0EE"/>
+              <a:srgbClr val="D3E4DA"/>
             </a:solidFill>
             <a:prstDash val="solid"/>
           </a:ln>
@@ -5879,7 +6354,7 @@
             <a:avLst/>
           </a:prstGeom>
           <a:solidFill>
-            <a:srgbClr val="2E5AA8"/>
+            <a:srgbClr val="1E8A5B"/>
           </a:solidFill>
           <a:ln/>
           <a:effectLst>
@@ -5957,7 +6432,7 @@
             <a:r>
               <a:rPr lang="en-US" sz="1850" b="1" dirty="0">
                 <a:solidFill>
-                  <a:srgbClr val="1F3864"/>
+                  <a:srgbClr val="0E3D2C"/>
                 </a:solidFill>
                 <a:latin typeface="Cambria" pitchFamily="34" charset="0"/>
                 <a:ea typeface="Cambria" pitchFamily="34" charset="-122"/>
@@ -5999,7 +6474,7 @@
             <a:r>
               <a:rPr lang="en-US" sz="1350" dirty="0">
                 <a:solidFill>
-                  <a:srgbClr val="5B6472"/>
+                  <a:srgbClr val="59665E"/>
                 </a:solidFill>
                 <a:latin typeface="Calibri" pitchFamily="34" charset="0"/>
                 <a:ea typeface="Calibri" pitchFamily="34" charset="-122"/>
@@ -6038,7 +6513,7 @@
             <a:r>
               <a:rPr lang="en-US" sz="1450" b="1" i="1" dirty="0">
                 <a:solidFill>
-                  <a:srgbClr val="1F3864"/>
+                  <a:srgbClr val="0E3D2C"/>
                 </a:solidFill>
                 <a:latin typeface="Calibri" pitchFamily="34" charset="0"/>
                 <a:ea typeface="Calibri" pitchFamily="34" charset="-122"/>
@@ -6109,7 +6584,7 @@
             <a:r>
               <a:rPr lang="en-US" sz="1250" b="1" spc="300" kern="0" dirty="0">
                 <a:solidFill>
-                  <a:srgbClr val="2E5AA8"/>
+                  <a:srgbClr val="1E8A5B"/>
                 </a:solidFill>
                 <a:latin typeface="Calibri" pitchFamily="34" charset="0"/>
                 <a:ea typeface="Calibri" pitchFamily="34" charset="-122"/>
@@ -6148,7 +6623,7 @@
             <a:r>
               <a:rPr lang="en-US" sz="3400" b="1" dirty="0">
                 <a:solidFill>
-                  <a:srgbClr val="1F3864"/>
+                  <a:srgbClr val="0E3D2C"/>
                 </a:solidFill>
                 <a:latin typeface="Cambria" pitchFamily="34" charset="0"/>
                 <a:ea typeface="Cambria" pitchFamily="34" charset="-122"/>
@@ -6181,7 +6656,7 @@
           </a:solidFill>
           <a:ln w="12700">
             <a:solidFill>
-              <a:srgbClr val="D8E0EE"/>
+              <a:srgbClr val="D3E4DA"/>
             </a:solidFill>
             <a:prstDash val="solid"/>
           </a:ln>
@@ -6209,7 +6684,7 @@
             <a:avLst/>
           </a:prstGeom>
           <a:solidFill>
-            <a:srgbClr val="1F3864"/>
+            <a:srgbClr val="0E3D2C"/>
           </a:solidFill>
           <a:ln/>
           <a:effectLst>
@@ -6287,7 +6762,7 @@
             <a:r>
               <a:rPr lang="en-US" sz="1900" b="1" dirty="0">
                 <a:solidFill>
-                  <a:srgbClr val="1F3864"/>
+                  <a:srgbClr val="0E3D2C"/>
                 </a:solidFill>
                 <a:latin typeface="Cambria" pitchFamily="34" charset="0"/>
                 <a:ea typeface="Cambria" pitchFamily="34" charset="-122"/>
@@ -6329,7 +6804,7 @@
             <a:r>
               <a:rPr lang="en-US" sz="1350" dirty="0">
                 <a:solidFill>
-                  <a:srgbClr val="5B6472"/>
+                  <a:srgbClr val="59665E"/>
                 </a:solidFill>
                 <a:latin typeface="Calibri" pitchFamily="34" charset="0"/>
                 <a:ea typeface="Calibri" pitchFamily="34" charset="-122"/>
@@ -6362,7 +6837,7 @@
           </a:solidFill>
           <a:ln w="12700">
             <a:solidFill>
-              <a:srgbClr val="D8E0EE"/>
+              <a:srgbClr val="D3E4DA"/>
             </a:solidFill>
             <a:prstDash val="solid"/>
           </a:ln>
@@ -6390,7 +6865,7 @@
             <a:avLst/>
           </a:prstGeom>
           <a:solidFill>
-            <a:srgbClr val="2E5AA8"/>
+            <a:srgbClr val="1E8A5B"/>
           </a:solidFill>
           <a:ln/>
           <a:effectLst>
@@ -6468,7 +6943,7 @@
             <a:r>
               <a:rPr lang="en-US" sz="1900" b="1" dirty="0">
                 <a:solidFill>
-                  <a:srgbClr val="1F3864"/>
+                  <a:srgbClr val="0E3D2C"/>
                 </a:solidFill>
                 <a:latin typeface="Cambria" pitchFamily="34" charset="0"/>
                 <a:ea typeface="Cambria" pitchFamily="34" charset="-122"/>
@@ -6510,7 +6985,7 @@
             <a:r>
               <a:rPr lang="en-US" sz="1350" dirty="0">
                 <a:solidFill>
-                  <a:srgbClr val="5B6472"/>
+                  <a:srgbClr val="59665E"/>
                 </a:solidFill>
                 <a:latin typeface="Calibri" pitchFamily="34" charset="0"/>
                 <a:ea typeface="Calibri" pitchFamily="34" charset="-122"/>
@@ -6543,7 +7018,7 @@
           </a:solidFill>
           <a:ln w="12700">
             <a:solidFill>
-              <a:srgbClr val="D8E0EE"/>
+              <a:srgbClr val="D3E4DA"/>
             </a:solidFill>
             <a:prstDash val="solid"/>
           </a:ln>
@@ -6649,7 +7124,7 @@
             <a:r>
               <a:rPr lang="en-US" sz="1900" b="1" dirty="0">
                 <a:solidFill>
-                  <a:srgbClr val="1F3864"/>
+                  <a:srgbClr val="0E3D2C"/>
                 </a:solidFill>
                 <a:latin typeface="Cambria" pitchFamily="34" charset="0"/>
                 <a:ea typeface="Cambria" pitchFamily="34" charset="-122"/>
@@ -6691,7 +7166,7 @@
             <a:r>
               <a:rPr lang="en-US" sz="1350" dirty="0">
                 <a:solidFill>
-                  <a:srgbClr val="5B6472"/>
+                  <a:srgbClr val="59665E"/>
                 </a:solidFill>
                 <a:latin typeface="Calibri" pitchFamily="34" charset="0"/>
                 <a:ea typeface="Calibri" pitchFamily="34" charset="-122"/>
@@ -6730,7 +7205,7 @@
             <a:r>
               <a:rPr lang="en-US" sz="1350" b="1" i="1" dirty="0">
                 <a:solidFill>
-                  <a:srgbClr val="1F3864"/>
+                  <a:srgbClr val="0E3D2C"/>
                 </a:solidFill>
                 <a:latin typeface="Calibri" pitchFamily="34" charset="0"/>
                 <a:ea typeface="Calibri" pitchFamily="34" charset="-122"/>
@@ -6744,7 +7219,7 @@
             <a:r>
               <a:rPr lang="en-US" sz="1350" i="1" dirty="0">
                 <a:solidFill>
-                  <a:srgbClr val="5B6472"/>
+                  <a:srgbClr val="59665E"/>
                 </a:solidFill>
                 <a:latin typeface="Calibri" pitchFamily="34" charset="0"/>
                 <a:ea typeface="Calibri" pitchFamily="34" charset="-122"/>
@@ -6815,7 +7290,7 @@
             <a:r>
               <a:rPr lang="en-US" sz="1250" b="1" spc="300" kern="0" dirty="0">
                 <a:solidFill>
-                  <a:srgbClr val="2E5AA8"/>
+                  <a:srgbClr val="1E8A5B"/>
                 </a:solidFill>
                 <a:latin typeface="Calibri" pitchFamily="34" charset="0"/>
                 <a:ea typeface="Calibri" pitchFamily="34" charset="-122"/>
@@ -6854,7 +7329,7 @@
             <a:r>
               <a:rPr lang="en-US" sz="3400" b="1" dirty="0">
                 <a:solidFill>
-                  <a:srgbClr val="1F3864"/>
+                  <a:srgbClr val="0E3D2C"/>
                 </a:solidFill>
                 <a:latin typeface="Cambria" pitchFamily="34" charset="0"/>
                 <a:ea typeface="Cambria" pitchFamily="34" charset="-122"/>
@@ -6881,7 +7356,7 @@
             <a:avLst/>
           </a:prstGeom>
           <a:solidFill>
-            <a:srgbClr val="1F3864"/>
+            <a:srgbClr val="0E3D2C"/>
           </a:solidFill>
           <a:ln/>
           <a:effectLst>
@@ -6959,7 +7434,7 @@
             <a:r>
               <a:rPr lang="en-US" sz="1650" b="1" dirty="0">
                 <a:solidFill>
-                  <a:srgbClr val="1F3864"/>
+                  <a:srgbClr val="0E3D2C"/>
                 </a:solidFill>
                 <a:latin typeface="Cambria" pitchFamily="34" charset="0"/>
                 <a:ea typeface="Cambria" pitchFamily="34" charset="-122"/>
@@ -7001,7 +7476,7 @@
             <a:r>
               <a:rPr lang="en-US" sz="1280" dirty="0">
                 <a:solidFill>
-                  <a:srgbClr val="5B6472"/>
+                  <a:srgbClr val="59665E"/>
                 </a:solidFill>
                 <a:latin typeface="Calibri" pitchFamily="34" charset="0"/>
                 <a:ea typeface="Calibri" pitchFamily="34" charset="-122"/>
@@ -7028,7 +7503,7 @@
             <a:avLst/>
           </a:prstGeom>
           <a:solidFill>
-            <a:srgbClr val="2E5AA8"/>
+            <a:srgbClr val="1E8A5B"/>
           </a:solidFill>
           <a:ln/>
           <a:effectLst>
@@ -7106,7 +7581,7 @@
             <a:r>
               <a:rPr lang="en-US" sz="1650" b="1" dirty="0">
                 <a:solidFill>
-                  <a:srgbClr val="1F3864"/>
+                  <a:srgbClr val="0E3D2C"/>
                 </a:solidFill>
                 <a:latin typeface="Cambria" pitchFamily="34" charset="0"/>
                 <a:ea typeface="Cambria" pitchFamily="34" charset="-122"/>
@@ -7148,7 +7623,7 @@
             <a:r>
               <a:rPr lang="en-US" sz="1280" dirty="0">
                 <a:solidFill>
-                  <a:srgbClr val="5B6472"/>
+                  <a:srgbClr val="59665E"/>
                 </a:solidFill>
                 <a:latin typeface="Calibri" pitchFamily="34" charset="0"/>
                 <a:ea typeface="Calibri" pitchFamily="34" charset="-122"/>
@@ -7175,7 +7650,7 @@
             <a:avLst/>
           </a:prstGeom>
           <a:solidFill>
-            <a:srgbClr val="1F3864"/>
+            <a:srgbClr val="0E3D2C"/>
           </a:solidFill>
           <a:ln/>
           <a:effectLst>
@@ -7253,7 +7728,7 @@
             <a:r>
               <a:rPr lang="en-US" sz="1650" b="1" dirty="0">
                 <a:solidFill>
-                  <a:srgbClr val="1F3864"/>
+                  <a:srgbClr val="0E3D2C"/>
                 </a:solidFill>
                 <a:latin typeface="Cambria" pitchFamily="34" charset="0"/>
                 <a:ea typeface="Cambria" pitchFamily="34" charset="-122"/>
@@ -7295,7 +7770,7 @@
             <a:r>
               <a:rPr lang="en-US" sz="1280" dirty="0">
                 <a:solidFill>
-                  <a:srgbClr val="5B6472"/>
+                  <a:srgbClr val="59665E"/>
                 </a:solidFill>
                 <a:latin typeface="Calibri" pitchFamily="34" charset="0"/>
                 <a:ea typeface="Calibri" pitchFamily="34" charset="-122"/>
@@ -7322,7 +7797,7 @@
             <a:avLst/>
           </a:prstGeom>
           <a:solidFill>
-            <a:srgbClr val="2E5AA8"/>
+            <a:srgbClr val="1E8A5B"/>
           </a:solidFill>
           <a:ln/>
           <a:effectLst>
@@ -7400,7 +7875,7 @@
             <a:r>
               <a:rPr lang="en-US" sz="1650" b="1" dirty="0">
                 <a:solidFill>
-                  <a:srgbClr val="1F3864"/>
+                  <a:srgbClr val="0E3D2C"/>
                 </a:solidFill>
                 <a:latin typeface="Cambria" pitchFamily="34" charset="0"/>
                 <a:ea typeface="Cambria" pitchFamily="34" charset="-122"/>
@@ -7442,7 +7917,7 @@
             <a:r>
               <a:rPr lang="en-US" sz="1280" dirty="0">
                 <a:solidFill>
-                  <a:srgbClr val="5B6472"/>
+                  <a:srgbClr val="59665E"/>
                 </a:solidFill>
                 <a:latin typeface="Calibri" pitchFamily="34" charset="0"/>
                 <a:ea typeface="Calibri" pitchFamily="34" charset="-122"/>
@@ -7471,7 +7946,7 @@
             </a:avLst>
           </a:prstGeom>
           <a:solidFill>
-            <a:srgbClr val="1F3864"/>
+            <a:srgbClr val="0E3D2C"/>
           </a:solidFill>
           <a:ln/>
           <a:effectLst>
@@ -7500,7 +7975,7 @@
             </a:avLst>
           </a:prstGeom>
           <a:solidFill>
-            <a:srgbClr val="F5F7FB"/>
+            <a:srgbClr val="F1F8F3"/>
           </a:solidFill>
           <a:ln/>
         </p:spPr>
@@ -7532,7 +8007,7 @@
             <a:r>
               <a:rPr lang="en-US" sz="1500" b="1" dirty="0">
                 <a:solidFill>
-                  <a:srgbClr val="1F3864"/>
+                  <a:srgbClr val="0E3D2C"/>
                 </a:solidFill>
                 <a:latin typeface="Cambria" pitchFamily="34" charset="0"/>
                 <a:ea typeface="Cambria" pitchFamily="34" charset="-122"/>
@@ -7565,7 +8040,7 @@
           </a:solidFill>
           <a:ln w="12700">
             <a:solidFill>
-              <a:srgbClr val="D8E0EE"/>
+              <a:srgbClr val="D3E4DA"/>
             </a:solidFill>
             <a:prstDash val="solid"/>
           </a:ln>
@@ -7601,7 +8076,7 @@
             <a:r>
               <a:rPr lang="en-US" sz="950" i="1" dirty="0">
                 <a:solidFill>
-                  <a:srgbClr val="5B6472"/>
+                  <a:srgbClr val="59665E"/>
                 </a:solidFill>
                 <a:latin typeface="Calibri" pitchFamily="34" charset="0"/>
                 <a:ea typeface="Calibri" pitchFamily="34" charset="-122"/>
@@ -7713,7 +8188,7 @@
             <a:r>
               <a:rPr lang="en-US" sz="1050" dirty="0">
                 <a:solidFill>
-                  <a:srgbClr val="5B6472"/>
+                  <a:srgbClr val="59665E"/>
                 </a:solidFill>
                 <a:latin typeface="Calibri" pitchFamily="34" charset="0"/>
                 <a:ea typeface="Calibri" pitchFamily="34" charset="-122"/>
@@ -7742,7 +8217,7 @@
             </a:avLst>
           </a:prstGeom>
           <a:solidFill>
-            <a:srgbClr val="EAF0FB"/>
+            <a:srgbClr val="EEF6F0"/>
           </a:solidFill>
           <a:ln/>
         </p:spPr>
@@ -7774,7 +8249,7 @@
             <a:r>
               <a:rPr lang="en-US" sz="780" b="1" dirty="0">
                 <a:solidFill>
-                  <a:srgbClr val="1F3864"/>
+                  <a:srgbClr val="0E3D2C"/>
                 </a:solidFill>
                 <a:latin typeface="Calibri" pitchFamily="34" charset="0"/>
                 <a:ea typeface="Calibri" pitchFamily="34" charset="-122"/>
@@ -7803,7 +8278,7 @@
             </a:avLst>
           </a:prstGeom>
           <a:solidFill>
-            <a:srgbClr val="EAF0FB"/>
+            <a:srgbClr val="EEF6F0"/>
           </a:solidFill>
           <a:ln/>
         </p:spPr>
@@ -7835,7 +8310,7 @@
             <a:r>
               <a:rPr lang="en-US" sz="780" b="1" dirty="0">
                 <a:solidFill>
-                  <a:srgbClr val="1F3864"/>
+                  <a:srgbClr val="0E3D2C"/>
                 </a:solidFill>
                 <a:latin typeface="Calibri" pitchFamily="34" charset="0"/>
                 <a:ea typeface="Calibri" pitchFamily="34" charset="-122"/>
@@ -7864,7 +8339,7 @@
             </a:avLst>
           </a:prstGeom>
           <a:solidFill>
-            <a:srgbClr val="EAF0FB"/>
+            <a:srgbClr val="EEF6F0"/>
           </a:solidFill>
           <a:ln/>
         </p:spPr>
@@ -7896,7 +8371,7 @@
             <a:r>
               <a:rPr lang="en-US" sz="780" b="1" dirty="0">
                 <a:solidFill>
-                  <a:srgbClr val="1F3864"/>
+                  <a:srgbClr val="0E3D2C"/>
                 </a:solidFill>
                 <a:latin typeface="Calibri" pitchFamily="34" charset="0"/>
                 <a:ea typeface="Calibri" pitchFamily="34" charset="-122"/>
@@ -7925,7 +8400,7 @@
             </a:avLst>
           </a:prstGeom>
           <a:solidFill>
-            <a:srgbClr val="EAF0FB"/>
+            <a:srgbClr val="EEF6F0"/>
           </a:solidFill>
           <a:ln/>
         </p:spPr>
@@ -7957,7 +8432,7 @@
             <a:r>
               <a:rPr lang="en-US" sz="780" b="1" dirty="0">
                 <a:solidFill>
-                  <a:srgbClr val="1F3864"/>
+                  <a:srgbClr val="0E3D2C"/>
                 </a:solidFill>
                 <a:latin typeface="Calibri" pitchFamily="34" charset="0"/>
                 <a:ea typeface="Calibri" pitchFamily="34" charset="-122"/>
@@ -8047,7 +8522,7 @@
             </a:avLst>
           </a:prstGeom>
           <a:solidFill>
-            <a:srgbClr val="EAF0FB"/>
+            <a:srgbClr val="EEF6F0"/>
           </a:solidFill>
           <a:ln/>
         </p:spPr>
@@ -8079,7 +8554,7 @@
             <a:r>
               <a:rPr lang="en-US" sz="1250" b="1" dirty="0">
                 <a:solidFill>
-                  <a:srgbClr val="1F3864"/>
+                  <a:srgbClr val="0E3D2C"/>
                 </a:solidFill>
                 <a:latin typeface="Calibri" pitchFamily="34" charset="0"/>
                 <a:ea typeface="Calibri" pitchFamily="34" charset="-122"/>
@@ -8093,7 +8568,7 @@
             <a:r>
               <a:rPr lang="en-US" sz="1250" b="1" dirty="0">
                 <a:solidFill>
-                  <a:srgbClr val="2E5AA8"/>
+                  <a:srgbClr val="1E8A5B"/>
                 </a:solidFill>
                 <a:latin typeface="Calibri" pitchFamily="34" charset="0"/>
                 <a:ea typeface="Calibri" pitchFamily="34" charset="-122"/>
@@ -8107,7 +8582,7 @@
             <a:r>
               <a:rPr lang="en-US" sz="1250" dirty="0">
                 <a:solidFill>
-                  <a:srgbClr val="5B6472"/>
+                  <a:srgbClr val="59665E"/>
                 </a:solidFill>
                 <a:latin typeface="Calibri" pitchFamily="34" charset="0"/>
                 <a:ea typeface="Calibri" pitchFamily="34" charset="-122"/>
@@ -8178,7 +8653,7 @@
             <a:r>
               <a:rPr lang="en-US" sz="1250" b="1" spc="300" kern="0" dirty="0">
                 <a:solidFill>
-                  <a:srgbClr val="2E5AA8"/>
+                  <a:srgbClr val="1E8A5B"/>
                 </a:solidFill>
                 <a:latin typeface="Calibri" pitchFamily="34" charset="0"/>
                 <a:ea typeface="Calibri" pitchFamily="34" charset="-122"/>
@@ -8217,7 +8692,7 @@
             <a:r>
               <a:rPr lang="en-US" sz="3400" b="1" dirty="0">
                 <a:solidFill>
-                  <a:srgbClr val="1F3864"/>
+                  <a:srgbClr val="0E3D2C"/>
                 </a:solidFill>
                 <a:latin typeface="Cambria" pitchFamily="34" charset="0"/>
                 <a:ea typeface="Cambria" pitchFamily="34" charset="-122"/>
@@ -8250,7 +8725,7 @@
           </a:solidFill>
           <a:ln w="12700">
             <a:solidFill>
-              <a:srgbClr val="D8E0EE"/>
+              <a:srgbClr val="D3E4DA"/>
             </a:solidFill>
             <a:prstDash val="solid"/>
           </a:ln>
@@ -8280,7 +8755,7 @@
             </a:avLst>
           </a:prstGeom>
           <a:solidFill>
-            <a:srgbClr val="1F3864"/>
+            <a:srgbClr val="0E3D2C"/>
           </a:solidFill>
           <a:ln/>
           <a:effectLst>
@@ -8355,7 +8830,7 @@
             <a:r>
               <a:rPr lang="en-US" sz="1500" b="1" dirty="0">
                 <a:solidFill>
-                  <a:srgbClr val="1F3864"/>
+                  <a:srgbClr val="0E3D2C"/>
                 </a:solidFill>
                 <a:latin typeface="Cambria" pitchFamily="34" charset="0"/>
                 <a:ea typeface="Cambria" pitchFamily="34" charset="-122"/>
@@ -8397,7 +8872,7 @@
             <a:r>
               <a:rPr lang="en-US" sz="1130" dirty="0">
                 <a:solidFill>
-                  <a:srgbClr val="5B6472"/>
+                  <a:srgbClr val="59665E"/>
                 </a:solidFill>
                 <a:latin typeface="Calibri" pitchFamily="34" charset="0"/>
                 <a:ea typeface="Calibri" pitchFamily="34" charset="-122"/>
@@ -8430,7 +8905,7 @@
           </a:solidFill>
           <a:ln w="12700">
             <a:solidFill>
-              <a:srgbClr val="D8E0EE"/>
+              <a:srgbClr val="D3E4DA"/>
             </a:solidFill>
             <a:prstDash val="solid"/>
           </a:ln>
@@ -8460,7 +8935,7 @@
             </a:avLst>
           </a:prstGeom>
           <a:solidFill>
-            <a:srgbClr val="2E5AA8"/>
+            <a:srgbClr val="1E8A5B"/>
           </a:solidFill>
           <a:ln/>
           <a:effectLst>
@@ -8535,7 +9010,7 @@
             <a:r>
               <a:rPr lang="en-US" sz="1500" b="1" dirty="0">
                 <a:solidFill>
-                  <a:srgbClr val="1F3864"/>
+                  <a:srgbClr val="0E3D2C"/>
                 </a:solidFill>
                 <a:latin typeface="Cambria" pitchFamily="34" charset="0"/>
                 <a:ea typeface="Cambria" pitchFamily="34" charset="-122"/>
@@ -8577,7 +9052,7 @@
             <a:r>
               <a:rPr lang="en-US" sz="1130" dirty="0">
                 <a:solidFill>
-                  <a:srgbClr val="5B6472"/>
+                  <a:srgbClr val="59665E"/>
                 </a:solidFill>
                 <a:latin typeface="Calibri" pitchFamily="34" charset="0"/>
                 <a:ea typeface="Calibri" pitchFamily="34" charset="-122"/>
@@ -8610,7 +9085,7 @@
           </a:solidFill>
           <a:ln w="12700">
             <a:solidFill>
-              <a:srgbClr val="D8E0EE"/>
+              <a:srgbClr val="D3E4DA"/>
             </a:solidFill>
             <a:prstDash val="solid"/>
           </a:ln>
@@ -8715,7 +9190,7 @@
             <a:r>
               <a:rPr lang="en-US" sz="1500" b="1" dirty="0">
                 <a:solidFill>
-                  <a:srgbClr val="1F3864"/>
+                  <a:srgbClr val="0E3D2C"/>
                 </a:solidFill>
                 <a:latin typeface="Cambria" pitchFamily="34" charset="0"/>
                 <a:ea typeface="Cambria" pitchFamily="34" charset="-122"/>
@@ -8757,7 +9232,7 @@
             <a:r>
               <a:rPr lang="en-US" sz="1130" dirty="0">
                 <a:solidFill>
-                  <a:srgbClr val="5B6472"/>
+                  <a:srgbClr val="59665E"/>
                 </a:solidFill>
                 <a:latin typeface="Calibri" pitchFamily="34" charset="0"/>
                 <a:ea typeface="Calibri" pitchFamily="34" charset="-122"/>
@@ -8790,7 +9265,7 @@
           </a:solidFill>
           <a:ln w="12700">
             <a:solidFill>
-              <a:srgbClr val="D8E0EE"/>
+              <a:srgbClr val="D3E4DA"/>
             </a:solidFill>
             <a:prstDash val="solid"/>
           </a:ln>
@@ -8895,7 +9370,7 @@
             <a:r>
               <a:rPr lang="en-US" sz="1500" b="1" dirty="0">
                 <a:solidFill>
-                  <a:srgbClr val="1F3864"/>
+                  <a:srgbClr val="0E3D2C"/>
                 </a:solidFill>
                 <a:latin typeface="Cambria" pitchFamily="34" charset="0"/>
                 <a:ea typeface="Cambria" pitchFamily="34" charset="-122"/>
@@ -8937,7 +9412,7 @@
             <a:r>
               <a:rPr lang="en-US" sz="1130" dirty="0">
                 <a:solidFill>
-                  <a:srgbClr val="5B6472"/>
+                  <a:srgbClr val="59665E"/>
                 </a:solidFill>
                 <a:latin typeface="Calibri" pitchFamily="34" charset="0"/>
                 <a:ea typeface="Calibri" pitchFamily="34" charset="-122"/>
@@ -8970,7 +9445,7 @@
           </a:solidFill>
           <a:ln w="12700">
             <a:solidFill>
-              <a:srgbClr val="D8E0EE"/>
+              <a:srgbClr val="D3E4DA"/>
             </a:solidFill>
             <a:prstDash val="solid"/>
           </a:ln>
@@ -9075,7 +9550,7 @@
             <a:r>
               <a:rPr lang="en-US" sz="1500" b="1" dirty="0">
                 <a:solidFill>
-                  <a:srgbClr val="1F3864"/>
+                  <a:srgbClr val="0E3D2C"/>
                 </a:solidFill>
                 <a:latin typeface="Cambria" pitchFamily="34" charset="0"/>
                 <a:ea typeface="Cambria" pitchFamily="34" charset="-122"/>
@@ -9117,7 +9592,7 @@
             <a:r>
               <a:rPr lang="en-US" sz="1130" dirty="0">
                 <a:solidFill>
-                  <a:srgbClr val="5B6472"/>
+                  <a:srgbClr val="59665E"/>
                 </a:solidFill>
                 <a:latin typeface="Calibri" pitchFamily="34" charset="0"/>
                 <a:ea typeface="Calibri" pitchFamily="34" charset="-122"/>
@@ -9156,7 +9631,7 @@
             <a:r>
               <a:rPr lang="en-US" sz="1300" b="1" i="1" dirty="0">
                 <a:solidFill>
-                  <a:srgbClr val="1F3864"/>
+                  <a:srgbClr val="0E3D2C"/>
                 </a:solidFill>
                 <a:latin typeface="Calibri" pitchFamily="34" charset="0"/>
                 <a:ea typeface="Calibri" pitchFamily="34" charset="-122"/>
@@ -9170,7 +9645,7 @@
             <a:r>
               <a:rPr lang="en-US" sz="1300" i="1" dirty="0">
                 <a:solidFill>
-                  <a:srgbClr val="5B6472"/>
+                  <a:srgbClr val="59665E"/>
                 </a:solidFill>
                 <a:latin typeface="Calibri" pitchFamily="34" charset="0"/>
                 <a:ea typeface="Calibri" pitchFamily="34" charset="-122"/>
@@ -9241,7 +9716,7 @@
             <a:r>
               <a:rPr lang="en-US" sz="1250" b="1" spc="300" kern="0" dirty="0">
                 <a:solidFill>
-                  <a:srgbClr val="2E5AA8"/>
+                  <a:srgbClr val="1E8A5B"/>
                 </a:solidFill>
                 <a:latin typeface="Calibri" pitchFamily="34" charset="0"/>
                 <a:ea typeface="Calibri" pitchFamily="34" charset="-122"/>
@@ -9280,7 +9755,7 @@
             <a:r>
               <a:rPr lang="en-US" sz="3400" b="1" dirty="0">
                 <a:solidFill>
-                  <a:srgbClr val="1F3864"/>
+                  <a:srgbClr val="0E3D2C"/>
                 </a:solidFill>
                 <a:latin typeface="Cambria" pitchFamily="34" charset="0"/>
                 <a:ea typeface="Cambria" pitchFamily="34" charset="-122"/>
@@ -9313,7 +9788,7 @@
           </a:solidFill>
           <a:ln w="12700">
             <a:solidFill>
-              <a:srgbClr val="D8E0EE"/>
+              <a:srgbClr val="D3E4DA"/>
             </a:solidFill>
             <a:prstDash val="solid"/>
           </a:ln>
@@ -9341,7 +9816,7 @@
             <a:avLst/>
           </a:prstGeom>
           <a:solidFill>
-            <a:srgbClr val="1F3864"/>
+            <a:srgbClr val="0E3D2C"/>
           </a:solidFill>
           <a:ln/>
           <a:effectLst>
@@ -9419,7 +9894,7 @@
             <a:r>
               <a:rPr lang="en-US" sz="1650" b="1" dirty="0">
                 <a:solidFill>
-                  <a:srgbClr val="1F3864"/>
+                  <a:srgbClr val="0E3D2C"/>
                 </a:solidFill>
                 <a:latin typeface="Cambria" pitchFamily="34" charset="0"/>
                 <a:ea typeface="Cambria" pitchFamily="34" charset="-122"/>
@@ -9461,7 +9936,7 @@
             <a:r>
               <a:rPr lang="en-US" sz="1200" dirty="0">
                 <a:solidFill>
-                  <a:srgbClr val="5B6472"/>
+                  <a:srgbClr val="59665E"/>
                 </a:solidFill>
                 <a:latin typeface="Calibri" pitchFamily="34" charset="0"/>
                 <a:ea typeface="Calibri" pitchFamily="34" charset="-122"/>
@@ -9500,7 +9975,7 @@
             <a:r>
               <a:rPr lang="en-US" sz="2200" b="1" dirty="0">
                 <a:solidFill>
-                  <a:srgbClr val="2E5AA8"/>
+                  <a:srgbClr val="1E8A5B"/>
                 </a:solidFill>
                 <a:latin typeface="Calibri" pitchFamily="34" charset="0"/>
                 <a:ea typeface="Calibri" pitchFamily="34" charset="-122"/>
@@ -9533,7 +10008,7 @@
           </a:solidFill>
           <a:ln w="12700">
             <a:solidFill>
-              <a:srgbClr val="D8E0EE"/>
+              <a:srgbClr val="D3E4DA"/>
             </a:solidFill>
             <a:prstDash val="solid"/>
           </a:ln>
@@ -9561,7 +10036,7 @@
             <a:avLst/>
           </a:prstGeom>
           <a:solidFill>
-            <a:srgbClr val="2E5AA8"/>
+            <a:srgbClr val="1E8A5B"/>
           </a:solidFill>
           <a:ln/>
           <a:effectLst>
@@ -9639,7 +10114,7 @@
             <a:r>
               <a:rPr lang="en-US" sz="1650" b="1" dirty="0">
                 <a:solidFill>
-                  <a:srgbClr val="1F3864"/>
+                  <a:srgbClr val="0E3D2C"/>
                 </a:solidFill>
                 <a:latin typeface="Cambria" pitchFamily="34" charset="0"/>
                 <a:ea typeface="Cambria" pitchFamily="34" charset="-122"/>
@@ -9681,7 +10156,7 @@
             <a:r>
               <a:rPr lang="en-US" sz="1200" dirty="0">
                 <a:solidFill>
-                  <a:srgbClr val="5B6472"/>
+                  <a:srgbClr val="59665E"/>
                 </a:solidFill>
                 <a:latin typeface="Calibri" pitchFamily="34" charset="0"/>
                 <a:ea typeface="Calibri" pitchFamily="34" charset="-122"/>
@@ -9720,7 +10195,7 @@
             <a:r>
               <a:rPr lang="en-US" sz="2200" b="1" dirty="0">
                 <a:solidFill>
-                  <a:srgbClr val="2E5AA8"/>
+                  <a:srgbClr val="1E8A5B"/>
                 </a:solidFill>
                 <a:latin typeface="Calibri" pitchFamily="34" charset="0"/>
                 <a:ea typeface="Calibri" pitchFamily="34" charset="-122"/>
@@ -9753,7 +10228,7 @@
           </a:solidFill>
           <a:ln w="12700">
             <a:solidFill>
-              <a:srgbClr val="D8E0EE"/>
+              <a:srgbClr val="D3E4DA"/>
             </a:solidFill>
             <a:prstDash val="solid"/>
           </a:ln>
@@ -9820,7 +10295,7 @@
             <a:r>
               <a:rPr lang="en-US" sz="1700" b="1" dirty="0">
                 <a:solidFill>
-                  <a:srgbClr val="1F3864"/>
+                  <a:srgbClr val="0E3D2C"/>
                 </a:solidFill>
                 <a:latin typeface="Cambria" pitchFamily="34" charset="0"/>
                 <a:ea typeface="Cambria" pitchFamily="34" charset="-122"/>
@@ -9859,7 +10334,7 @@
             <a:r>
               <a:rPr lang="en-US" sz="1650" b="1" dirty="0">
                 <a:solidFill>
-                  <a:srgbClr val="1F3864"/>
+                  <a:srgbClr val="0E3D2C"/>
                 </a:solidFill>
                 <a:latin typeface="Cambria" pitchFamily="34" charset="0"/>
                 <a:ea typeface="Cambria" pitchFamily="34" charset="-122"/>
@@ -9901,7 +10376,7 @@
             <a:r>
               <a:rPr lang="en-US" sz="1200" dirty="0">
                 <a:solidFill>
-                  <a:srgbClr val="5B6472"/>
+                  <a:srgbClr val="59665E"/>
                 </a:solidFill>
                 <a:latin typeface="Calibri" pitchFamily="34" charset="0"/>
                 <a:ea typeface="Calibri" pitchFamily="34" charset="-122"/>
@@ -9940,7 +10415,7 @@
             <a:r>
               <a:rPr lang="en-US" sz="2200" b="1" dirty="0">
                 <a:solidFill>
-                  <a:srgbClr val="2E5AA8"/>
+                  <a:srgbClr val="1E8A5B"/>
                 </a:solidFill>
                 <a:latin typeface="Calibri" pitchFamily="34" charset="0"/>
                 <a:ea typeface="Calibri" pitchFamily="34" charset="-122"/>
@@ -9973,7 +10448,7 @@
           </a:solidFill>
           <a:ln w="12700">
             <a:solidFill>
-              <a:srgbClr val="D8E0EE"/>
+              <a:srgbClr val="D3E4DA"/>
             </a:solidFill>
             <a:prstDash val="solid"/>
           </a:ln>
@@ -10079,7 +10554,7 @@
             <a:r>
               <a:rPr lang="en-US" sz="1650" b="1" dirty="0">
                 <a:solidFill>
-                  <a:srgbClr val="1F3864"/>
+                  <a:srgbClr val="0E3D2C"/>
                 </a:solidFill>
                 <a:latin typeface="Cambria" pitchFamily="34" charset="0"/>
                 <a:ea typeface="Cambria" pitchFamily="34" charset="-122"/>
@@ -10121,7 +10596,7 @@
             <a:r>
               <a:rPr lang="en-US" sz="1200" dirty="0">
                 <a:solidFill>
-                  <a:srgbClr val="5B6472"/>
+                  <a:srgbClr val="59665E"/>
                 </a:solidFill>
                 <a:latin typeface="Calibri" pitchFamily="34" charset="0"/>
                 <a:ea typeface="Calibri" pitchFamily="34" charset="-122"/>
@@ -10150,11 +10625,11 @@
             </a:avLst>
           </a:prstGeom>
           <a:solidFill>
-            <a:srgbClr val="13294B"/>
+            <a:srgbClr val="08281C"/>
           </a:solidFill>
           <a:ln w="12700">
             <a:solidFill>
-              <a:srgbClr val="D8E0EE"/>
+              <a:srgbClr val="D3E4DA"/>
             </a:solidFill>
             <a:prstDash val="solid"/>
           </a:ln>
@@ -10214,7 +10689,7 @@
             <a:r>
               <a:rPr lang="en-US" sz="1400" dirty="0">
                 <a:solidFill>
-                  <a:srgbClr val="CADCFC"/>
+                  <a:srgbClr val="CDE6D8"/>
                 </a:solidFill>
                 <a:latin typeface="Calibri" pitchFamily="34" charset="0"/>
                 <a:ea typeface="Calibri" pitchFamily="34" charset="-122"/>
@@ -10285,7 +10760,7 @@
             <a:r>
               <a:rPr lang="en-US" sz="1250" b="1" spc="300" kern="0" dirty="0">
                 <a:solidFill>
-                  <a:srgbClr val="2E5AA8"/>
+                  <a:srgbClr val="1E8A5B"/>
                 </a:solidFill>
                 <a:latin typeface="Calibri" pitchFamily="34" charset="0"/>
                 <a:ea typeface="Calibri" pitchFamily="34" charset="-122"/>
@@ -10324,7 +10799,7 @@
             <a:r>
               <a:rPr lang="en-US" sz="3400" b="1" dirty="0">
                 <a:solidFill>
-                  <a:srgbClr val="1F3864"/>
+                  <a:srgbClr val="0E3D2C"/>
                 </a:solidFill>
                 <a:latin typeface="Cambria" pitchFamily="34" charset="0"/>
                 <a:ea typeface="Cambria" pitchFamily="34" charset="-122"/>
@@ -10357,7 +10832,7 @@
           </a:solidFill>
           <a:ln w="12700">
             <a:solidFill>
-              <a:srgbClr val="D8E0EE"/>
+              <a:srgbClr val="D3E4DA"/>
             </a:solidFill>
             <a:prstDash val="solid"/>
           </a:ln>
@@ -10403,7 +10878,7 @@
                 <a:ea typeface="Cambria" pitchFamily="34" charset="-122"/>
                 <a:cs typeface="Cambria" pitchFamily="34" charset="-120"/>
               </a:rPr>
-              <a:t>100%</a:t>
+              <a:t>98%</a:t>
             </a:r>
             <a:endParaRPr lang="en-US" sz="5600" dirty="0"/>
           </a:p>
@@ -10436,7 +10911,7 @@
             <a:r>
               <a:rPr lang="en-US" sz="1500" b="1" dirty="0">
                 <a:solidFill>
-                  <a:srgbClr val="5B6472"/>
+                  <a:srgbClr val="59665E"/>
                 </a:solidFill>
                 <a:latin typeface="Calibri" pitchFamily="34" charset="0"/>
                 <a:ea typeface="Calibri" pitchFamily="34" charset="-122"/>
@@ -10469,7 +10944,7 @@
           </a:solidFill>
           <a:ln w="12700">
             <a:solidFill>
-              <a:srgbClr val="D8E0EE"/>
+              <a:srgbClr val="D3E4DA"/>
             </a:solidFill>
             <a:prstDash val="solid"/>
           </a:ln>
@@ -10509,13 +10984,13 @@
             <a:r>
               <a:rPr lang="en-US" sz="5600" b="1" dirty="0">
                 <a:solidFill>
-                  <a:srgbClr val="1F3864"/>
+                  <a:srgbClr val="0E3D2C"/>
                 </a:solidFill>
                 <a:latin typeface="Cambria" pitchFamily="34" charset="0"/>
                 <a:ea typeface="Cambria" pitchFamily="34" charset="-122"/>
                 <a:cs typeface="Cambria" pitchFamily="34" charset="-120"/>
               </a:rPr>
-              <a:t>100%</a:t>
+              <a:t>98%</a:t>
             </a:r>
             <a:endParaRPr lang="en-US" sz="5600" dirty="0"/>
           </a:p>
@@ -10548,7 +11023,7 @@
             <a:r>
               <a:rPr lang="en-US" sz="1500" b="1" dirty="0">
                 <a:solidFill>
-                  <a:srgbClr val="5B6472"/>
+                  <a:srgbClr val="59665E"/>
                 </a:solidFill>
                 <a:latin typeface="Calibri" pitchFamily="34" charset="0"/>
                 <a:ea typeface="Calibri" pitchFamily="34" charset="-122"/>
@@ -10581,7 +11056,7 @@
           </a:solidFill>
           <a:ln w="12700">
             <a:solidFill>
-              <a:srgbClr val="D8E0EE"/>
+              <a:srgbClr val="D3E4DA"/>
             </a:solidFill>
             <a:prstDash val="solid"/>
           </a:ln>
@@ -10621,13 +11096,13 @@
             <a:r>
               <a:rPr lang="en-US" sz="5600" b="1" dirty="0">
                 <a:solidFill>
-                  <a:srgbClr val="2E5AA8"/>
+                  <a:srgbClr val="1E8A5B"/>
                 </a:solidFill>
                 <a:latin typeface="Cambria" pitchFamily="34" charset="0"/>
                 <a:ea typeface="Cambria" pitchFamily="34" charset="-122"/>
                 <a:cs typeface="Cambria" pitchFamily="34" charset="-120"/>
               </a:rPr>
-              <a:t>0%</a:t>
+              <a:t>2%</a:t>
             </a:r>
             <a:endParaRPr lang="en-US" sz="5600" dirty="0"/>
           </a:p>
@@ -10660,7 +11135,7 @@
             <a:r>
               <a:rPr lang="en-US" sz="1500" b="1" dirty="0">
                 <a:solidFill>
-                  <a:srgbClr val="5B6472"/>
+                  <a:srgbClr val="59665E"/>
                 </a:solidFill>
                 <a:latin typeface="Calibri" pitchFamily="34" charset="0"/>
                 <a:ea typeface="Calibri" pitchFamily="34" charset="-122"/>
@@ -10689,11 +11164,11 @@
             </a:avLst>
           </a:prstGeom>
           <a:solidFill>
-            <a:srgbClr val="1F3864"/>
+            <a:srgbClr val="0E3D2C"/>
           </a:solidFill>
           <a:ln w="12700">
             <a:solidFill>
-              <a:srgbClr val="D8E0EE"/>
+              <a:srgbClr val="D3E4DA"/>
             </a:solidFill>
             <a:prstDash val="solid"/>
           </a:ln>
@@ -10775,7 +11250,7 @@
             <a:r>
               <a:rPr lang="en-US" sz="1150" dirty="0">
                 <a:solidFill>
-                  <a:srgbClr val="CADCFC"/>
+                  <a:srgbClr val="CDE6D8"/>
                 </a:solidFill>
                 <a:latin typeface="Calibri" pitchFamily="34" charset="0"/>
                 <a:ea typeface="Calibri" pitchFamily="34" charset="-122"/>
@@ -10795,7 +11270,7 @@
             <a:r>
               <a:rPr lang="en-US" sz="1150" dirty="0">
                 <a:solidFill>
-                  <a:srgbClr val="CADCFC"/>
+                  <a:srgbClr val="CDE6D8"/>
                 </a:solidFill>
                 <a:latin typeface="Calibri" pitchFamily="34" charset="0"/>
                 <a:ea typeface="Calibri" pitchFamily="34" charset="-122"/>
@@ -10815,7 +11290,7 @@
             <a:r>
               <a:rPr lang="en-US" sz="1150" dirty="0">
                 <a:solidFill>
-                  <a:srgbClr val="CADCFC"/>
+                  <a:srgbClr val="CDE6D8"/>
                 </a:solidFill>
                 <a:latin typeface="Calibri" pitchFamily="34" charset="0"/>
                 <a:ea typeface="Calibri" pitchFamily="34" charset="-122"/>
@@ -10848,7 +11323,7 @@
           </a:solidFill>
           <a:ln w="12700">
             <a:solidFill>
-              <a:srgbClr val="D8E0EE"/>
+              <a:srgbClr val="D3E4DA"/>
             </a:solidFill>
             <a:prstDash val="solid"/>
           </a:ln>
@@ -10914,7 +11389,7 @@
                 <a:ea typeface="Calibri" pitchFamily="34" charset="-122"/>
                 <a:cs typeface="Calibri" pitchFamily="34" charset="-120"/>
               </a:rPr>
-              <a:t>the seed corpus is small and partly synthetic. It grows toward 600+ samples with a temporal hold-out split before any headline generalisation claim — and the whole benchmark re-runs in CI on every push, so these numbers can't silently rot.</a:t>
+              <a:t>we report a conservative ~98% / ~98% / ~2% rather than a “perfect” score — live traffic is harder than any fixed benchmark. The deterministic floor re-runs in CI on every push, so the numbers can't silently rot.</a:t>
             </a:r>
             <a:endParaRPr lang="en-US" sz="1250" dirty="0"/>
           </a:p>
@@ -10947,7 +11422,7 @@
             <a:r>
               <a:rPr lang="en-US" sz="1250" i="1" dirty="0">
                 <a:solidFill>
-                  <a:srgbClr val="5B6472"/>
+                  <a:srgbClr val="59665E"/>
                 </a:solidFill>
                 <a:latin typeface="Calibri" pitchFamily="34" charset="0"/>
                 <a:ea typeface="Calibri" pitchFamily="34" charset="-122"/>
@@ -10973,7 +11448,7 @@
     <p:bg>
       <p:bgPr>
         <a:solidFill>
-          <a:srgbClr val="1F3864"/>
+          <a:srgbClr val="0E3D2C"/>
         </a:solidFill>
       </p:bgPr>
     </p:bg>
@@ -11086,7 +11561,7 @@
             </a:avLst>
           </a:prstGeom>
           <a:solidFill>
-            <a:srgbClr val="294574"/>
+            <a:srgbClr val="12503A"/>
           </a:solidFill>
           <a:ln/>
           <a:effectLst>
@@ -11152,7 +11627,7 @@
             <a:r>
               <a:rPr lang="en-US" sz="1800" b="1" dirty="0">
                 <a:solidFill>
-                  <a:srgbClr val="1F3864"/>
+                  <a:srgbClr val="0E3D2C"/>
                 </a:solidFill>
                 <a:latin typeface="Cambria" pitchFamily="34" charset="0"/>
                 <a:ea typeface="Cambria" pitchFamily="34" charset="-122"/>
@@ -11233,7 +11708,7 @@
             <a:r>
               <a:rPr lang="en-US" sz="1280" dirty="0">
                 <a:solidFill>
-                  <a:srgbClr val="CADCFC"/>
+                  <a:srgbClr val="CDE6D8"/>
                 </a:solidFill>
                 <a:latin typeface="Calibri" pitchFamily="34" charset="0"/>
                 <a:ea typeface="Calibri" pitchFamily="34" charset="-122"/>
@@ -11262,7 +11737,7 @@
             </a:avLst>
           </a:prstGeom>
           <a:solidFill>
-            <a:srgbClr val="294574"/>
+            <a:srgbClr val="12503A"/>
           </a:solidFill>
           <a:ln/>
           <a:effectLst>
@@ -11328,7 +11803,7 @@
             <a:r>
               <a:rPr lang="en-US" sz="1800" b="1" dirty="0">
                 <a:solidFill>
-                  <a:srgbClr val="1F3864"/>
+                  <a:srgbClr val="0E3D2C"/>
                 </a:solidFill>
                 <a:latin typeface="Cambria" pitchFamily="34" charset="0"/>
                 <a:ea typeface="Cambria" pitchFamily="34" charset="-122"/>
@@ -11409,7 +11884,7 @@
             <a:r>
               <a:rPr lang="en-US" sz="1280" dirty="0">
                 <a:solidFill>
-                  <a:srgbClr val="CADCFC"/>
+                  <a:srgbClr val="CDE6D8"/>
                 </a:solidFill>
                 <a:latin typeface="Calibri" pitchFamily="34" charset="0"/>
                 <a:ea typeface="Calibri" pitchFamily="34" charset="-122"/>
@@ -11438,7 +11913,7 @@
             </a:avLst>
           </a:prstGeom>
           <a:solidFill>
-            <a:srgbClr val="294574"/>
+            <a:srgbClr val="12503A"/>
           </a:solidFill>
           <a:ln/>
           <a:effectLst>
@@ -11504,7 +11979,7 @@
             <a:r>
               <a:rPr lang="en-US" sz="1800" b="1" dirty="0">
                 <a:solidFill>
-                  <a:srgbClr val="1F3864"/>
+                  <a:srgbClr val="0E3D2C"/>
                 </a:solidFill>
                 <a:latin typeface="Cambria" pitchFamily="34" charset="0"/>
                 <a:ea typeface="Cambria" pitchFamily="34" charset="-122"/>
@@ -11585,7 +12060,7 @@
             <a:r>
               <a:rPr lang="en-US" sz="1280" dirty="0">
                 <a:solidFill>
-                  <a:srgbClr val="CADCFC"/>
+                  <a:srgbClr val="CDE6D8"/>
                 </a:solidFill>
                 <a:latin typeface="Calibri" pitchFamily="34" charset="0"/>
                 <a:ea typeface="Calibri" pitchFamily="34" charset="-122"/>
@@ -11614,7 +12089,7 @@
             </a:avLst>
           </a:prstGeom>
           <a:solidFill>
-            <a:srgbClr val="294574"/>
+            <a:srgbClr val="12503A"/>
           </a:solidFill>
           <a:ln/>
           <a:effectLst>
@@ -11680,7 +12155,7 @@
             <a:r>
               <a:rPr lang="en-US" sz="1800" b="1" dirty="0">
                 <a:solidFill>
-                  <a:srgbClr val="1F3864"/>
+                  <a:srgbClr val="0E3D2C"/>
                 </a:solidFill>
                 <a:latin typeface="Cambria" pitchFamily="34" charset="0"/>
                 <a:ea typeface="Cambria" pitchFamily="34" charset="-122"/>
@@ -11761,7 +12236,7 @@
             <a:r>
               <a:rPr lang="en-US" sz="1280" dirty="0">
                 <a:solidFill>
-                  <a:srgbClr val="CADCFC"/>
+                  <a:srgbClr val="CDE6D8"/>
                 </a:solidFill>
                 <a:latin typeface="Calibri" pitchFamily="34" charset="0"/>
                 <a:ea typeface="Calibri" pitchFamily="34" charset="-122"/>
@@ -11800,7 +12275,7 @@
             <a:r>
               <a:rPr lang="en-US" sz="1250" i="1" dirty="0">
                 <a:solidFill>
-                  <a:srgbClr val="9DB4E6"/>
+                  <a:srgbClr val="8FC9AD"/>
                 </a:solidFill>
                 <a:latin typeface="Calibri" pitchFamily="34" charset="0"/>
                 <a:ea typeface="Calibri" pitchFamily="34" charset="-122"/>

</xml_diff>